<commit_message>
Presentación al Comité: cambios de Seguridad y Relaciones Laborales
- Seguridad: fatalidades completas, veto en las dos misiones, regla 3, R1 y R7 nuevo
- Relaciones Laborales: petición 2 como respaldo a las reglas de no uso,
  validación solo para confianza, reglas iguales a la app, sin link público

Co-Authored-By: Claude Opus 5.5 <noreply@anthropic.com>
Claude-Session: https://claude.ai/code/session_01KNk188BQs5d5yrXcfpDDFP
</commit_message>
<xml_diff>
--- a/entregables/2026-10-08-presentacion-comite/academia-digital-misiones-comite.pptx
+++ b/entregables/2026-10-08-presentacion-comite/academia-digital-misiones-comite.pptx
@@ -583,7 +583,7 @@
           <a:lstStyle/>
           <a:p>
             <a:r>
-              <a:t>Tres condiciones para escalar: datos de planta validados, acuerdo con la CMCAP y una plataforma interna. Las misiones siguientes ya están en el mapa como «próximamente».</a:t>
+              <a:t>Tres condiciones para escalar: datos de planta validados, acuerdo de la CMCAP y una plataforma interna. Las misiones siguientes ya están en el mapa como «próximamente».</a:t>
             </a:r>
           </a:p>
         </p:txBody>
@@ -793,7 +793,7 @@
           <a:lstStyle/>
           <a:p>
             <a:r>
-              <a:t>Si el comité solo recuerda una lámina, es esta. Qué: misiones cortas en dos riesgos críticos. Cómo: validación con veto de Seguridad, y reglas laborales claras. Qué pedimos: expertos de planta, mandato para la CMCAP y su opinión sobre la siguiente misión.</a:t>
+              <a:t>Si el comité solo recuerda una lámina, es esta. Qué: misiones cortas en dos riesgos críticos. Cómo: validación con veto de Seguridad, y reglas laborales claras. Qué pedimos: expertos de planta, respaldo a las reglas de no uso que llevaremos a la CMCAP y su opinión sobre la siguiente misión.</a:t>
             </a:r>
           </a:p>
         </p:txBody>
@@ -863,7 +863,7 @@
           <a:lstStyle/>
           <a:p>
             <a:r>
-              <a:t>El dato que más pesa: una de las dos fatalidades fue una caída de altura. Ambas involucraron autorizaciones vencidas o inexistentes. Aclarar que la plataforma no autoriza ni certifica: la autorización la da la planta y la competencia la evalúa un evaluador en piso.</a:t>
+              <a:t>El dato que más pesa: una de las dos fatalidades fue una caída de altura. Ambas involucraron autorizaciones vencidas o inexistentes. La otra fatalidad fue de equipo móvil, candidato para una siguiente misión. Aclarar que la plataforma no autoriza ni certifica: la autorización la da la planta y la evaluación de competencia la define Seguridad de planta.</a:t>
             </a:r>
           </a:p>
         </p:txBody>
@@ -1073,7 +1073,7 @@
           <a:lstStyle/>
           <a:p>
             <a:r>
-              <a:t>Mensaje para el comité: el veto de Seguridad no fue un trámite; se usó y detuvo la liberación de LOTO hasta corregir. Operaciones pidió precisar la prueba de arranque, porque una banda puede no arrancar por un interbloqueo y dar un falso «energía cero». Relaciones Laborales limitó el piloto a personal de confianza.</a:t>
+              <a:t>Mensaje para el comité: el veto de Seguridad no fue un trámite; se usó y detuvo la liberación de las dos misiones hasta corregir. Operaciones pidió precisar la prueba de arranque, porque una banda puede no arrancar por un interbloqueo y dar un falso «energía cero». El Director decidió (D-011-4) que el piloto sea solo con personal de confianza hasta el acuerdo de la CMCAP; Relaciones Laborales precisó que el nuevo ingreso en un puesto sindicalizable cuenta como sindicalizado.</a:t>
             </a:r>
           </a:p>
         </p:txBody>
@@ -1143,7 +1143,7 @@
           <a:lstStyle/>
           <a:p>
             <a:r>
-              <a:t>Estas reglas están en la plataforma, en los documentos y en el guion del instructor. Las reglas 3 y 4 son las que más le importan al sindicato; por eso el piloto es solo con personal de confianza hasta tener el acuerdo de la CMCAP.</a:t>
+              <a:t>Estas reglas están en la plataforma, en los documentos y en el guion del instructor. Las reglas 3 y 4 son las que más le importan al sindicato; por eso el Director decidió que el piloto sea solo con personal de confianza hasta el acuerdo de la CMCAP (D-011-4). La regla 6 enseña la conducta esperada (LFT arts. 134 y 135). La política de facultad de detener el trabajo y la protección de quien la ejerce está pendiente de Seguridad y Jurídico Laboral; el material no promete que detenerse nunca se sanciona.</a:t>
             </a:r>
           </a:p>
         </p:txBody>
@@ -1283,7 +1283,7 @@
           <a:lstStyle/>
           <a:p>
             <a:r>
-              <a:t>R4 es el riesgo que más depende del comité: sin expertos de planta, el material no puede dejar de ser DEMO. R6: el link actual sirve para el piloto, pero la versión de operación debe vivir en la intranet o el LMS.</a:t>
+              <a:t>R4 es el riesgo que más depende del comité: sin expertos de planta, el material no puede dejar de ser DEMO. R6 y R7: el link actual es público; no se difunde fuera del piloto y la versión de operación debe vivir en la intranet o el LMS. R1 es también el criterio de paro del piloto.</a:t>
             </a:r>
           </a:p>
         </p:txBody>
@@ -6611,7 +6611,7 @@
                 </a:solidFill>
                 <a:latin typeface="Segoe UI"/>
               </a:rPr>
-              <a:t>Mientras tanto: solo personal de confianza e instructores.</a:t>
+              <a:t>Mientras tanto: solo personal de confianza (D-015).</a:t>
             </a:r>
           </a:p>
           <a:p>
@@ -6639,7 +6639,7 @@
                 </a:solidFill>
                 <a:latin typeface="Segoe UI"/>
               </a:rPr>
-              <a:t>Fecha: por definir con Relaciones Laborales.</a:t>
+              <a:t>Fecha: según el calendario de sesiones de la CMCAP.</a:t>
             </a:r>
           </a:p>
         </p:txBody>
@@ -7208,7 +7208,7 @@
         <p:spPr>
           <a:xfrm>
             <a:off x="658368" y="1737360"/>
-            <a:ext cx="10874959" cy="914400"/>
+            <a:ext cx="10874959" cy="1005840"/>
           </a:xfrm>
           <a:prstGeom prst="roundRect">
             <a:avLst>
@@ -7262,7 +7262,7 @@
         <p:spPr>
           <a:xfrm>
             <a:off x="658368" y="1737360"/>
-            <a:ext cx="91440" cy="914400"/>
+            <a:ext cx="91440" cy="1005840"/>
           </a:xfrm>
           <a:prstGeom prst="rect">
             <a:avLst/>
@@ -7305,7 +7305,7 @@
         </p:nvSpPr>
         <p:spPr>
           <a:xfrm>
-            <a:off x="932688" y="1965960"/>
+            <a:off x="932688" y="2011680"/>
             <a:ext cx="457200" cy="457200"/>
           </a:xfrm>
           <a:prstGeom prst="ellipse">
@@ -7349,7 +7349,7 @@
         </p:nvSpPr>
         <p:spPr>
           <a:xfrm>
-            <a:off x="932688" y="1956816"/>
+            <a:off x="932688" y="2002536"/>
             <a:ext cx="457200" cy="457200"/>
           </a:xfrm>
           <a:prstGeom prst="rect">
@@ -7388,7 +7388,7 @@
         </p:nvSpPr>
         <p:spPr>
           <a:xfrm>
-            <a:off x="1618488" y="1865376"/>
+            <a:off x="1618488" y="1847088"/>
             <a:ext cx="6309360" cy="310896"/>
           </a:xfrm>
           <a:prstGeom prst="rect">
@@ -7427,8 +7427,8 @@
         </p:nvSpPr>
         <p:spPr>
           <a:xfrm>
-            <a:off x="1618488" y="2194560"/>
-            <a:ext cx="6309360" cy="420624"/>
+            <a:off x="1618488" y="2157984"/>
+            <a:ext cx="6309360" cy="548640"/>
           </a:xfrm>
           <a:prstGeom prst="rect">
             <a:avLst/>
@@ -7447,7 +7447,7 @@
               </a:lnSpc>
             </a:pPr>
             <a:r>
-              <a:rPr sz="1050" b="0" i="0">
+              <a:rPr sz="1000" b="0" i="0">
                 <a:solidFill>
                   <a:srgbClr val="535E6E"/>
                 </a:solidFill>
@@ -7467,7 +7467,7 @@
         <p:spPr>
           <a:xfrm>
             <a:off x="8110728" y="1901952"/>
-            <a:ext cx="12801" cy="585216"/>
+            <a:ext cx="12801" cy="676656"/>
           </a:xfrm>
           <a:prstGeom prst="rect">
             <a:avLst/>
@@ -7511,7 +7511,7 @@
         <p:spPr>
           <a:xfrm>
             <a:off x="8293608" y="1737360"/>
-            <a:ext cx="3056839" cy="914400"/>
+            <a:ext cx="3056839" cy="1005840"/>
           </a:xfrm>
           <a:prstGeom prst="rect">
             <a:avLst/>
@@ -7549,8 +7549,8 @@
         </p:nvSpPr>
         <p:spPr>
           <a:xfrm>
-            <a:off x="658368" y="2770632"/>
-            <a:ext cx="10874959" cy="914400"/>
+            <a:off x="658368" y="2825496"/>
+            <a:ext cx="10874959" cy="1005840"/>
           </a:xfrm>
           <a:prstGeom prst="roundRect">
             <a:avLst>
@@ -7603,8 +7603,8 @@
         </p:nvSpPr>
         <p:spPr>
           <a:xfrm>
-            <a:off x="658368" y="2770632"/>
-            <a:ext cx="91440" cy="914400"/>
+            <a:off x="658368" y="2825496"/>
+            <a:ext cx="91440" cy="1005840"/>
           </a:xfrm>
           <a:prstGeom prst="rect">
             <a:avLst/>
@@ -7647,7 +7647,7 @@
         </p:nvSpPr>
         <p:spPr>
           <a:xfrm>
-            <a:off x="932688" y="2999232"/>
+            <a:off x="932688" y="3099816"/>
             <a:ext cx="457200" cy="457200"/>
           </a:xfrm>
           <a:prstGeom prst="ellipse">
@@ -7691,7 +7691,7 @@
         </p:nvSpPr>
         <p:spPr>
           <a:xfrm>
-            <a:off x="932688" y="2990088"/>
+            <a:off x="932688" y="3090672"/>
             <a:ext cx="457200" cy="457200"/>
           </a:xfrm>
           <a:prstGeom prst="rect">
@@ -7730,7 +7730,7 @@
         </p:nvSpPr>
         <p:spPr>
           <a:xfrm>
-            <a:off x="1618488" y="2898648"/>
+            <a:off x="1618488" y="2935224"/>
             <a:ext cx="6309360" cy="310896"/>
           </a:xfrm>
           <a:prstGeom prst="rect">
@@ -7756,7 +7756,7 @@
                 </a:solidFill>
                 <a:latin typeface="Segoe UI Semibold"/>
               </a:rPr>
-              <a:t>Mandato para llevar la propuesta a la CMCAP</a:t>
+              <a:t>Respaldo a las reglas de no uso como compromiso de la empresa</a:t>
             </a:r>
           </a:p>
         </p:txBody>
@@ -7769,8 +7769,8 @@
         </p:nvSpPr>
         <p:spPr>
           <a:xfrm>
-            <a:off x="1618488" y="3227832"/>
-            <a:ext cx="6309360" cy="420624"/>
+            <a:off x="1618488" y="3246120"/>
+            <a:ext cx="6309360" cy="548640"/>
           </a:xfrm>
           <a:prstGeom prst="rect">
             <a:avLst/>
@@ -7789,13 +7789,13 @@
               </a:lnSpc>
             </a:pPr>
             <a:r>
-              <a:rPr sz="1050" b="0" i="0">
+              <a:rPr sz="1000" b="0" i="0">
                 <a:solidFill>
                   <a:srgbClr val="535E6E"/>
                 </a:solidFill>
                 <a:latin typeface="Segoe UI"/>
               </a:rPr>
-              <a:t>Con Relaciones Laborales y Jurídico Laboral, para incluir al personal sindicalizado.</a:t>
+              <a:t>La propuesta irá a la CMCAP por decisión del Director (D-011-4). Pedimos que las direcciones respalden las reglas 3, 4 y 5 para que la representación de la empresa en la CMCAP pueda sostenerlas ante el sindicato.</a:t>
             </a:r>
           </a:p>
         </p:txBody>
@@ -7808,8 +7808,8 @@
         </p:nvSpPr>
         <p:spPr>
           <a:xfrm>
-            <a:off x="8110728" y="2935224"/>
-            <a:ext cx="12801" cy="585216"/>
+            <a:off x="8110728" y="2990088"/>
+            <a:ext cx="12801" cy="676656"/>
           </a:xfrm>
           <a:prstGeom prst="rect">
             <a:avLst/>
@@ -7852,8 +7852,8 @@
         </p:nvSpPr>
         <p:spPr>
           <a:xfrm>
-            <a:off x="8293608" y="2770632"/>
-            <a:ext cx="3056839" cy="914400"/>
+            <a:off x="8293608" y="2825496"/>
+            <a:ext cx="3056839" cy="1005840"/>
           </a:xfrm>
           <a:prstGeom prst="rect">
             <a:avLst/>
@@ -7878,7 +7878,7 @@
                 </a:solidFill>
                 <a:latin typeface="Segoe UI"/>
               </a:rPr>
-              <a:t>Sin costo adicional. Fecha por definir con Relaciones Laborales.</a:t>
+              <a:t>Sin costo adicional. Fecha: según el calendario de la CMCAP.</a:t>
             </a:r>
           </a:p>
         </p:txBody>
@@ -7891,8 +7891,8 @@
         </p:nvSpPr>
         <p:spPr>
           <a:xfrm>
-            <a:off x="658368" y="3803904"/>
-            <a:ext cx="10874959" cy="914400"/>
+            <a:off x="658368" y="3913632"/>
+            <a:ext cx="10874959" cy="1005840"/>
           </a:xfrm>
           <a:prstGeom prst="roundRect">
             <a:avLst>
@@ -7945,8 +7945,8 @@
         </p:nvSpPr>
         <p:spPr>
           <a:xfrm>
-            <a:off x="658368" y="3803904"/>
-            <a:ext cx="91440" cy="914400"/>
+            <a:off x="658368" y="3913632"/>
+            <a:ext cx="91440" cy="1005840"/>
           </a:xfrm>
           <a:prstGeom prst="rect">
             <a:avLst/>
@@ -7989,7 +7989,7 @@
         </p:nvSpPr>
         <p:spPr>
           <a:xfrm>
-            <a:off x="932688" y="4032504"/>
+            <a:off x="932688" y="4187952"/>
             <a:ext cx="457200" cy="457200"/>
           </a:xfrm>
           <a:prstGeom prst="ellipse">
@@ -8033,7 +8033,7 @@
         </p:nvSpPr>
         <p:spPr>
           <a:xfrm>
-            <a:off x="932688" y="4023360"/>
+            <a:off x="932688" y="4178808"/>
             <a:ext cx="457200" cy="457200"/>
           </a:xfrm>
           <a:prstGeom prst="rect">
@@ -8072,7 +8072,7 @@
         </p:nvSpPr>
         <p:spPr>
           <a:xfrm>
-            <a:off x="1618488" y="3931920"/>
+            <a:off x="1618488" y="4023360"/>
             <a:ext cx="6309360" cy="310896"/>
           </a:xfrm>
           <a:prstGeom prst="rect">
@@ -8111,8 +8111,8 @@
         </p:nvSpPr>
         <p:spPr>
           <a:xfrm>
-            <a:off x="1618488" y="4261104"/>
-            <a:ext cx="6309360" cy="420624"/>
+            <a:off x="1618488" y="4334256"/>
+            <a:ext cx="6309360" cy="548640"/>
           </a:xfrm>
           <a:prstGeom prst="rect">
             <a:avLst/>
@@ -8131,7 +8131,7 @@
               </a:lnSpc>
             </a:pPr>
             <a:r>
-              <a:rPr sz="1050" b="0" i="0">
+              <a:rPr sz="1000" b="0" i="0">
                 <a:solidFill>
                   <a:srgbClr val="535E6E"/>
                 </a:solidFill>
@@ -8150,8 +8150,8 @@
         </p:nvSpPr>
         <p:spPr>
           <a:xfrm>
-            <a:off x="8110728" y="3968496"/>
-            <a:ext cx="12801" cy="585216"/>
+            <a:off x="8110728" y="4078224"/>
+            <a:ext cx="12801" cy="676656"/>
           </a:xfrm>
           <a:prstGeom prst="rect">
             <a:avLst/>
@@ -8194,8 +8194,8 @@
         </p:nvSpPr>
         <p:spPr>
           <a:xfrm>
-            <a:off x="8293608" y="3803904"/>
-            <a:ext cx="3056839" cy="914400"/>
+            <a:off x="8293608" y="3913632"/>
+            <a:ext cx="3056839" cy="1005840"/>
           </a:xfrm>
           <a:prstGeom prst="rect">
             <a:avLst/>
@@ -8233,8 +8233,8 @@
         </p:nvSpPr>
         <p:spPr>
           <a:xfrm>
-            <a:off x="658368" y="4837176"/>
-            <a:ext cx="10874959" cy="914400"/>
+            <a:off x="658368" y="5001768"/>
+            <a:ext cx="10874959" cy="1005840"/>
           </a:xfrm>
           <a:prstGeom prst="roundRect">
             <a:avLst>
@@ -8287,8 +8287,8 @@
         </p:nvSpPr>
         <p:spPr>
           <a:xfrm>
-            <a:off x="658368" y="4837176"/>
-            <a:ext cx="91440" cy="914400"/>
+            <a:off x="658368" y="5001768"/>
+            <a:ext cx="91440" cy="1005840"/>
           </a:xfrm>
           <a:prstGeom prst="rect">
             <a:avLst/>
@@ -8331,7 +8331,7 @@
         </p:nvSpPr>
         <p:spPr>
           <a:xfrm>
-            <a:off x="932688" y="5065776"/>
+            <a:off x="932688" y="5276088"/>
             <a:ext cx="457200" cy="457200"/>
           </a:xfrm>
           <a:prstGeom prst="ellipse">
@@ -8375,7 +8375,7 @@
         </p:nvSpPr>
         <p:spPr>
           <a:xfrm>
-            <a:off x="932688" y="5056632"/>
+            <a:off x="932688" y="5266944"/>
             <a:ext cx="457200" cy="457200"/>
           </a:xfrm>
           <a:prstGeom prst="rect">
@@ -8414,7 +8414,7 @@
         </p:nvSpPr>
         <p:spPr>
           <a:xfrm>
-            <a:off x="1618488" y="4965192"/>
+            <a:off x="1618488" y="5111496"/>
             <a:ext cx="6309360" cy="310896"/>
           </a:xfrm>
           <a:prstGeom prst="rect">
@@ -8453,8 +8453,8 @@
         </p:nvSpPr>
         <p:spPr>
           <a:xfrm>
-            <a:off x="1618488" y="5294376"/>
-            <a:ext cx="6309360" cy="420624"/>
+            <a:off x="1618488" y="5422392"/>
+            <a:ext cx="6309360" cy="548640"/>
           </a:xfrm>
           <a:prstGeom prst="rect">
             <a:avLst/>
@@ -8473,7 +8473,7 @@
               </a:lnSpc>
             </a:pPr>
             <a:r>
-              <a:rPr sz="1050" b="0" i="0">
+              <a:rPr sz="1000" b="0" i="0">
                 <a:solidFill>
                   <a:srgbClr val="535E6E"/>
                 </a:solidFill>
@@ -8492,8 +8492,8 @@
         </p:nvSpPr>
         <p:spPr>
           <a:xfrm>
-            <a:off x="8110728" y="5001768"/>
-            <a:ext cx="12801" cy="585216"/>
+            <a:off x="8110728" y="5166360"/>
+            <a:ext cx="12801" cy="676656"/>
           </a:xfrm>
           <a:prstGeom prst="rect">
             <a:avLst/>
@@ -8536,8 +8536,8 @@
         </p:nvSpPr>
         <p:spPr>
           <a:xfrm>
-            <a:off x="8293608" y="4837176"/>
-            <a:ext cx="3056839" cy="914400"/>
+            <a:off x="8293608" y="5001768"/>
+            <a:ext cx="3056839" cy="1005840"/>
           </a:xfrm>
           <a:prstGeom prst="rect">
             <a:avLst/>
@@ -8575,7 +8575,7 @@
         </p:nvSpPr>
         <p:spPr>
           <a:xfrm>
-            <a:off x="658368" y="5888736"/>
+            <a:off x="658368" y="6089904"/>
             <a:ext cx="10874959" cy="365760"/>
           </a:xfrm>
           <a:prstGeom prst="rect">
@@ -9087,7 +9087,7 @@
                 </a:solidFill>
                 <a:latin typeface="Segoe UI"/>
               </a:rPr>
-              <a:t>Lanzar el piloto controlado del módulo EAF; asistente de IA oculto; sindicalizados solo con acuerdo de la CMCAP.</a:t>
+              <a:t>Piloto controlado del módulo EAF; asistente de IA oculto; sindicalizados solo con acuerdo de la CMCAP y validación de Jurídico Laboral.</a:t>
             </a:r>
           </a:p>
         </p:txBody>
@@ -9838,7 +9838,7 @@
                 </a:solidFill>
                 <a:latin typeface="Segoe UI"/>
               </a:rPr>
-              <a:t>rawcdn.githack.com/diegocardonaguzman03-maker/HR/fa25ff0f34fb2eee70bc7d8df4b7645c63c0f7a1/apps/academy/web/index.html</a:t>
+              <a:t>link de prueba; se comparte a solicitud con Capacitación y Desarrollo.</a:t>
             </a:r>
           </a:p>
           <a:p>
@@ -9875,7 +9875,7 @@
                 </a:solidFill>
                 <a:latin typeface="Segoe UI"/>
               </a:rPr>
-              <a:t>entregables/2026-10-07-lanzamiento-piloto-misiones/</a:t>
+              <a:t>guía del instructor, hoja de observación y metas, con Capacitación y Desarrollo.</a:t>
             </a:r>
           </a:p>
           <a:p>
@@ -9903,7 +9903,7 @@
                 </a:solidFill>
                 <a:latin typeface="Segoe UI"/>
               </a:rPr>
-              <a:t>Dictámenes: </a:t>
+              <a:t>Dictámenes de Seguridad, Operativo y Relaciones Laborales: </a:t>
             </a:r>
             <a:r>
               <a:rPr sz="1050" b="0" i="0">
@@ -9912,7 +9912,7 @@
                 </a:solidFill>
                 <a:latin typeface="Segoe UI"/>
               </a:rPr>
-              <a:t>apps/academy/docs/reviews/ (Seguridad, Operativo y Relaciones Laborales)</a:t>
+              <a:t>a solicitud con Capacitación y Desarrollo.</a:t>
             </a:r>
           </a:p>
         </p:txBody>
@@ -10260,7 +10260,7 @@
                 </a:solidFill>
                 <a:latin typeface="Segoe UI"/>
               </a:rPr>
-              <a:t>Dos riesgos críticos, validados por Seguridad, Operaciones y Relaciones Laborales, sin datos de planta inventados.</a:t>
+              <a:t>Práctica (DEMO) en dos riesgos críticos, revisada por Seguridad, Operaciones y Relaciones Laborales para personal de confianza.</a:t>
             </a:r>
           </a:p>
         </p:txBody>
@@ -10813,7 +10813,7 @@
                 </a:solidFill>
                 <a:latin typeface="Segoe UI Semibold"/>
               </a:rPr>
-              <a:t>Seguridad tiene veto y lo ejerció: el material se liberó solo después de corregir todos sus hallazgos.</a:t>
+              <a:t>Seguridad tiene veto y lo ejerció: el material se liberó solo después de corregir los hallazgos que condicionaban la liberación.</a:t>
             </a:r>
           </a:p>
         </p:txBody>
@@ -10964,7 +10964,7 @@
                 </a:solidFill>
                 <a:latin typeface="Segoe UI"/>
               </a:rPr>
-              <a:t>No se usa para evaluar a nadie.</a:t>
+              <a:t>No se usa para evaluar desempeño, escalafón ni sanciones.</a:t>
             </a:r>
           </a:p>
         </p:txBody>
@@ -11266,7 +11266,7 @@
                 </a:solidFill>
                 <a:latin typeface="Segoe UI"/>
               </a:rPr>
-              <a:t>Mandato para ir a la CMCAP.</a:t>
+              <a:t>Respaldo a las reglas de no uso ante la CMCAP.</a:t>
             </a:r>
           </a:p>
           <a:p>
@@ -11661,7 +11661,7 @@
         <p:spPr>
           <a:xfrm>
             <a:off x="658368" y="2048256"/>
-            <a:ext cx="2478709" cy="1874519"/>
+            <a:ext cx="2478709" cy="2194560"/>
           </a:xfrm>
           <a:prstGeom prst="roundRect">
             <a:avLst>
@@ -11800,8 +11800,8 @@
         </p:nvSpPr>
         <p:spPr>
           <a:xfrm>
-            <a:off x="859536" y="3182112"/>
-            <a:ext cx="2076373" cy="658368"/>
+            <a:off x="841247" y="3145536"/>
+            <a:ext cx="2112949" cy="1005840"/>
           </a:xfrm>
           <a:prstGeom prst="rect">
             <a:avLst/>
@@ -11820,13 +11820,13 @@
               </a:lnSpc>
             </a:pPr>
             <a:r>
-              <a:rPr sz="1150" b="0" i="0">
+              <a:rPr sz="1050" b="0" i="0">
                 <a:solidFill>
                   <a:srgbClr val="535E6E"/>
                 </a:solidFill>
                 <a:latin typeface="Segoe UI"/>
               </a:rPr>
-              <a:t>fatalidades en 3 años; una por caída de altura en laminación</a:t>
+              <a:t>fatalidades en 3 años: un contratista cayó de altura en laminación y un empleado fue atropellado por equipo móvil en mina</a:t>
             </a:r>
           </a:p>
         </p:txBody>
@@ -11840,7 +11840,7 @@
         <p:spPr>
           <a:xfrm>
             <a:off x="3457117" y="2048256"/>
-            <a:ext cx="2478709" cy="1874519"/>
+            <a:ext cx="2478709" cy="2194560"/>
           </a:xfrm>
           <a:prstGeom prst="roundRect">
             <a:avLst>
@@ -11979,8 +11979,8 @@
         </p:nvSpPr>
         <p:spPr>
           <a:xfrm>
-            <a:off x="3658285" y="3182112"/>
-            <a:ext cx="2076373" cy="658368"/>
+            <a:off x="3639997" y="3145536"/>
+            <a:ext cx="2112949" cy="1005840"/>
           </a:xfrm>
           <a:prstGeom prst="rect">
             <a:avLst/>
@@ -11999,7 +11999,7 @@
               </a:lnSpc>
             </a:pPr>
             <a:r>
-              <a:rPr sz="1150" b="0" i="0">
+              <a:rPr sz="1050" b="0" i="0">
                 <a:solidFill>
                   <a:srgbClr val="535E6E"/>
                 </a:solidFill>
@@ -12019,7 +12019,7 @@
         <p:spPr>
           <a:xfrm>
             <a:off x="6255867" y="2048256"/>
-            <a:ext cx="2478709" cy="1874519"/>
+            <a:ext cx="2478709" cy="2194560"/>
           </a:xfrm>
           <a:prstGeom prst="roundRect">
             <a:avLst>
@@ -12158,8 +12158,8 @@
         </p:nvSpPr>
         <p:spPr>
           <a:xfrm>
-            <a:off x="6457035" y="3182112"/>
-            <a:ext cx="2076373" cy="658368"/>
+            <a:off x="6438747" y="3145536"/>
+            <a:ext cx="2112949" cy="1005840"/>
           </a:xfrm>
           <a:prstGeom prst="rect">
             <a:avLst/>
@@ -12178,7 +12178,7 @@
               </a:lnSpc>
             </a:pPr>
             <a:r>
-              <a:rPr sz="1150" b="0" i="0">
+              <a:rPr sz="1050" b="0" i="0">
                 <a:solidFill>
                   <a:srgbClr val="535E6E"/>
                 </a:solidFill>
@@ -12198,7 +12198,7 @@
         <p:spPr>
           <a:xfrm>
             <a:off x="9054617" y="2048256"/>
-            <a:ext cx="2478709" cy="1874519"/>
+            <a:ext cx="2478709" cy="2194560"/>
           </a:xfrm>
           <a:prstGeom prst="roundRect">
             <a:avLst>
@@ -12337,8 +12337,8 @@
         </p:nvSpPr>
         <p:spPr>
           <a:xfrm>
-            <a:off x="9255785" y="3182112"/>
-            <a:ext cx="2076373" cy="658368"/>
+            <a:off x="9237497" y="3145536"/>
+            <a:ext cx="2112949" cy="1005840"/>
           </a:xfrm>
           <a:prstGeom prst="rect">
             <a:avLst/>
@@ -12357,7 +12357,7 @@
               </a:lnSpc>
             </a:pPr>
             <a:r>
-              <a:rPr sz="1150" b="0" i="0">
+              <a:rPr sz="1050" b="0" i="0">
                 <a:solidFill>
                   <a:srgbClr val="535E6E"/>
                 </a:solidFill>
@@ -12376,8 +12376,8 @@
         </p:nvSpPr>
         <p:spPr>
           <a:xfrm>
-            <a:off x="658368" y="4288536"/>
-            <a:ext cx="10874959" cy="1554480"/>
+            <a:off x="658368" y="4535424"/>
+            <a:ext cx="10874959" cy="1463040"/>
           </a:xfrm>
           <a:prstGeom prst="roundRect">
             <a:avLst>
@@ -12424,8 +12424,8 @@
         </p:nvSpPr>
         <p:spPr>
           <a:xfrm>
-            <a:off x="658368" y="4288536"/>
-            <a:ext cx="100584" cy="1554480"/>
+            <a:off x="658368" y="4535424"/>
+            <a:ext cx="100584" cy="1463040"/>
           </a:xfrm>
           <a:prstGeom prst="rect">
             <a:avLst/>
@@ -12468,7 +12468,7 @@
         </p:nvSpPr>
         <p:spPr>
           <a:xfrm>
-            <a:off x="1024128" y="4489704"/>
+            <a:off x="1024128" y="4718304"/>
             <a:ext cx="10143439" cy="274320"/>
           </a:xfrm>
           <a:prstGeom prst="rect">
@@ -12507,8 +12507,8 @@
         </p:nvSpPr>
         <p:spPr>
           <a:xfrm>
-            <a:off x="1024128" y="4800600"/>
-            <a:ext cx="10143439" cy="960120"/>
+            <a:off x="1024128" y="5010912"/>
+            <a:ext cx="10143439" cy="914400"/>
           </a:xfrm>
           <a:prstGeom prst="rect">
             <a:avLst/>
@@ -12533,7 +12533,7 @@
                 </a:solidFill>
                 <a:latin typeface="Segoe UI"/>
               </a:rPr>
-              <a:t>Las dos fatalidades involucraron </a:t>
+              <a:t>Según el perfil de GASM, las dos fatalidades involucraron </a:t>
             </a:r>
             <a:r>
               <a:rPr sz="1350" b="1" i="0">
@@ -12551,7 +12551,7 @@
                 </a:solidFill>
                 <a:latin typeface="Segoe UI"/>
               </a:rPr>
-              <a:t>. La Academia no sustituye la certificación en piso ni la autorización de la planta: </a:t>
+              <a:t>. La Academia no sustituye la evaluación de competencia ni la autorización que otorga la planta: </a:t>
             </a:r>
             <a:r>
               <a:rPr sz="1350" b="1" i="0">
@@ -12608,7 +12608,7 @@
                 </a:solidFill>
                 <a:latin typeface="Segoe UI"/>
               </a:rPr>
-              <a:t>Fuente: perfil de GASM (01-company-profile), últimos 3 años. Datos de planeación; Seguridad los confirma con sus registros.</a:t>
+              <a:t>Fuente: perfil de GASM (01-company-profile), últimos 3 años. Datos de planeación; Seguridad y Jurídico Laboral los confirman antes de circular la presentación.</a:t>
             </a:r>
           </a:p>
         </p:txBody>
@@ -14154,7 +14154,7 @@
                 </a:solidFill>
                 <a:latin typeface="Segoe UI"/>
               </a:rPr>
-              <a:t>Identificar todos los peligros, aislar la energía de la luminaria, confirmar el rescate, inspeccionar el arnés, elegir un anclaje designado y verificar el espacio libre de caída.</a:t>
+              <a:t>Identificar todos los peligros, confirmar que la energía de la luminaria está aislada y poner tu candado, confirmar el rescate, inspeccionar el arnés, elegir un anclaje designado y verificar el espacio libre de caída.</a:t>
             </a:r>
           </a:p>
         </p:txBody>
@@ -14765,8 +14765,8 @@
         </p:nvSpPr>
         <p:spPr>
           <a:xfrm>
-            <a:off x="658368" y="1920240"/>
-            <a:ext cx="1954042" cy="786384"/>
+            <a:off x="658368" y="1901952"/>
+            <a:ext cx="1960626" cy="822960"/>
           </a:xfrm>
           <a:prstGeom prst="homePlate">
             <a:avLst>
@@ -14811,7 +14811,7 @@
         </p:nvSpPr>
         <p:spPr>
           <a:xfrm>
-            <a:off x="804672" y="2139696"/>
+            <a:off x="804672" y="2121408"/>
             <a:ext cx="1684477" cy="457200"/>
           </a:xfrm>
           <a:prstGeom prst="rect">
@@ -14850,7 +14850,7 @@
         </p:nvSpPr>
         <p:spPr>
           <a:xfrm>
-            <a:off x="804672" y="2542032"/>
+            <a:off x="804672" y="2523744"/>
             <a:ext cx="1711909" cy="384048"/>
           </a:xfrm>
           <a:prstGeom prst="rect">
@@ -14889,8 +14889,8 @@
         </p:nvSpPr>
         <p:spPr>
           <a:xfrm>
-            <a:off x="2470861" y="1920240"/>
-            <a:ext cx="1954042" cy="786384"/>
+            <a:off x="2470861" y="1901952"/>
+            <a:ext cx="1960626" cy="822960"/>
           </a:xfrm>
           <a:prstGeom prst="chevron">
             <a:avLst>
@@ -14935,8 +14935,8 @@
         </p:nvSpPr>
         <p:spPr>
           <a:xfrm>
-            <a:off x="2740426" y="2139696"/>
-            <a:ext cx="1561216" cy="457200"/>
+            <a:off x="2747010" y="2121408"/>
+            <a:ext cx="1554632" cy="457200"/>
           </a:xfrm>
           <a:prstGeom prst="rect">
             <a:avLst/>
@@ -14974,8 +14974,8 @@
         </p:nvSpPr>
         <p:spPr>
           <a:xfrm>
-            <a:off x="2740426" y="2542032"/>
-            <a:ext cx="1588648" cy="384048"/>
+            <a:off x="2747010" y="2523744"/>
+            <a:ext cx="1582064" cy="384048"/>
           </a:xfrm>
           <a:prstGeom prst="rect">
             <a:avLst/>
@@ -15013,8 +15013,8 @@
         </p:nvSpPr>
         <p:spPr>
           <a:xfrm>
-            <a:off x="4283354" y="1920240"/>
-            <a:ext cx="1954042" cy="786384"/>
+            <a:off x="4283354" y="1901952"/>
+            <a:ext cx="1960626" cy="822960"/>
           </a:xfrm>
           <a:prstGeom prst="chevron">
             <a:avLst>
@@ -15059,8 +15059,8 @@
         </p:nvSpPr>
         <p:spPr>
           <a:xfrm>
-            <a:off x="4552919" y="2139696"/>
-            <a:ext cx="1561216" cy="457200"/>
+            <a:off x="4559503" y="2121408"/>
+            <a:ext cx="1554632" cy="457200"/>
           </a:xfrm>
           <a:prstGeom prst="rect">
             <a:avLst/>
@@ -15098,8 +15098,8 @@
         </p:nvSpPr>
         <p:spPr>
           <a:xfrm>
-            <a:off x="4552919" y="2542032"/>
-            <a:ext cx="1588648" cy="384048"/>
+            <a:off x="4559503" y="2523744"/>
+            <a:ext cx="1582064" cy="384048"/>
           </a:xfrm>
           <a:prstGeom prst="rect">
             <a:avLst/>
@@ -15137,8 +15137,8 @@
         </p:nvSpPr>
         <p:spPr>
           <a:xfrm>
-            <a:off x="6095847" y="1920240"/>
-            <a:ext cx="1954042" cy="786384"/>
+            <a:off x="6095847" y="1901952"/>
+            <a:ext cx="1960626" cy="822960"/>
           </a:xfrm>
           <a:prstGeom prst="chevron">
             <a:avLst>
@@ -15183,8 +15183,8 @@
         </p:nvSpPr>
         <p:spPr>
           <a:xfrm>
-            <a:off x="6365412" y="2139696"/>
-            <a:ext cx="1561216" cy="457200"/>
+            <a:off x="6371996" y="2121408"/>
+            <a:ext cx="1554632" cy="457200"/>
           </a:xfrm>
           <a:prstGeom prst="rect">
             <a:avLst/>
@@ -15222,8 +15222,8 @@
         </p:nvSpPr>
         <p:spPr>
           <a:xfrm>
-            <a:off x="6365412" y="2542032"/>
-            <a:ext cx="1588648" cy="384048"/>
+            <a:off x="6371996" y="2523744"/>
+            <a:ext cx="1582064" cy="384048"/>
           </a:xfrm>
           <a:prstGeom prst="rect">
             <a:avLst/>
@@ -15261,8 +15261,8 @@
         </p:nvSpPr>
         <p:spPr>
           <a:xfrm>
-            <a:off x="7908340" y="1920240"/>
-            <a:ext cx="1954042" cy="786384"/>
+            <a:off x="7908340" y="1901952"/>
+            <a:ext cx="1960626" cy="822960"/>
           </a:xfrm>
           <a:prstGeom prst="chevron">
             <a:avLst>
@@ -15307,8 +15307,8 @@
         </p:nvSpPr>
         <p:spPr>
           <a:xfrm>
-            <a:off x="8177905" y="2139696"/>
-            <a:ext cx="1561216" cy="457200"/>
+            <a:off x="8184489" y="2121408"/>
+            <a:ext cx="1554632" cy="457200"/>
           </a:xfrm>
           <a:prstGeom prst="rect">
             <a:avLst/>
@@ -15346,8 +15346,8 @@
         </p:nvSpPr>
         <p:spPr>
           <a:xfrm>
-            <a:off x="8177905" y="2542032"/>
-            <a:ext cx="1588648" cy="384048"/>
+            <a:off x="8184489" y="2523744"/>
+            <a:ext cx="1582064" cy="384048"/>
           </a:xfrm>
           <a:prstGeom prst="rect">
             <a:avLst/>
@@ -15385,8 +15385,8 @@
         </p:nvSpPr>
         <p:spPr>
           <a:xfrm>
-            <a:off x="9720834" y="1920240"/>
-            <a:ext cx="1954042" cy="786384"/>
+            <a:off x="9720834" y="1901952"/>
+            <a:ext cx="1960626" cy="822960"/>
           </a:xfrm>
           <a:prstGeom prst="chevron">
             <a:avLst>
@@ -15431,8 +15431,8 @@
         </p:nvSpPr>
         <p:spPr>
           <a:xfrm>
-            <a:off x="9990399" y="2139696"/>
-            <a:ext cx="1561216" cy="457200"/>
+            <a:off x="9996982" y="2121408"/>
+            <a:ext cx="1554632" cy="457200"/>
           </a:xfrm>
           <a:prstGeom prst="rect">
             <a:avLst/>
@@ -15470,8 +15470,8 @@
         </p:nvSpPr>
         <p:spPr>
           <a:xfrm>
-            <a:off x="9990399" y="2542032"/>
-            <a:ext cx="1588648" cy="384048"/>
+            <a:off x="9996982" y="2523744"/>
+            <a:ext cx="1582064" cy="384048"/>
           </a:xfrm>
           <a:prstGeom prst="rect">
             <a:avLst/>
@@ -15509,7 +15509,7 @@
         </p:nvSpPr>
         <p:spPr>
           <a:xfrm>
-            <a:off x="841247" y="2825496"/>
+            <a:off x="841247" y="2852928"/>
             <a:ext cx="2331720" cy="237744"/>
           </a:xfrm>
           <a:prstGeom prst="rect">
@@ -15548,7 +15548,7 @@
         </p:nvSpPr>
         <p:spPr>
           <a:xfrm>
-            <a:off x="3172968" y="2825496"/>
+            <a:off x="3172968" y="2852928"/>
             <a:ext cx="2880360" cy="237744"/>
           </a:xfrm>
           <a:prstGeom prst="rect">
@@ -15587,7 +15587,7 @@
         </p:nvSpPr>
         <p:spPr>
           <a:xfrm>
-            <a:off x="6053327" y="2825496"/>
+            <a:off x="6053327" y="2852928"/>
             <a:ext cx="5388559" cy="237744"/>
           </a:xfrm>
           <a:prstGeom prst="rect">
@@ -15626,8 +15626,8 @@
         </p:nvSpPr>
         <p:spPr>
           <a:xfrm>
-            <a:off x="658368" y="3118103"/>
-            <a:ext cx="10874959" cy="676656"/>
+            <a:off x="658368" y="3127248"/>
+            <a:ext cx="10874959" cy="749808"/>
           </a:xfrm>
           <a:prstGeom prst="rect">
             <a:avLst/>
@@ -15672,8 +15672,8 @@
         </p:nvSpPr>
         <p:spPr>
           <a:xfrm>
-            <a:off x="841247" y="3118103"/>
-            <a:ext cx="2148839" cy="676656"/>
+            <a:off x="841247" y="3127248"/>
+            <a:ext cx="2148839" cy="749808"/>
           </a:xfrm>
           <a:prstGeom prst="rect">
             <a:avLst/>
@@ -15711,7 +15711,7 @@
         </p:nvSpPr>
         <p:spPr>
           <a:xfrm>
-            <a:off x="3172968" y="3392424"/>
+            <a:off x="3172968" y="3438144"/>
             <a:ext cx="128016" cy="128016"/>
           </a:xfrm>
           <a:prstGeom prst="ellipse">
@@ -15755,8 +15755,8 @@
         </p:nvSpPr>
         <p:spPr>
           <a:xfrm>
-            <a:off x="3392424" y="3118103"/>
-            <a:ext cx="2560320" cy="676656"/>
+            <a:off x="3392424" y="3127248"/>
+            <a:ext cx="2560320" cy="749808"/>
           </a:xfrm>
           <a:prstGeom prst="rect">
             <a:avLst/>
@@ -15775,13 +15775,13 @@
               </a:lnSpc>
             </a:pPr>
             <a:r>
-              <a:rPr sz="1100" b="1" i="0">
+              <a:rPr sz="1050" b="1" i="0">
                 <a:solidFill>
                   <a:srgbClr val="2B3340"/>
                 </a:solidFill>
                 <a:latin typeface="Segoe UI"/>
               </a:rPr>
-              <a:t>Veto levantado · sin hallazgos abiertos</a:t>
+              <a:t>Veto levantado en las dos misiones · nada abierto que condicione el piloto</a:t>
             </a:r>
           </a:p>
         </p:txBody>
@@ -15794,8 +15794,8 @@
         </p:nvSpPr>
         <p:spPr>
           <a:xfrm>
-            <a:off x="6053327" y="3118103"/>
-            <a:ext cx="5297119" cy="676656"/>
+            <a:off x="6053327" y="3127248"/>
+            <a:ext cx="5297119" cy="749808"/>
           </a:xfrm>
           <a:prstGeom prst="rect">
             <a:avLst/>
@@ -15820,7 +15820,7 @@
                 </a:solidFill>
                 <a:latin typeface="Segoe UI"/>
               </a:rPr>
-              <a:t>Vetó la misión LOTO y sus documentos. Se corrigieron 14 hallazgos y 5 de seguimiento: verificación de energía cero completa, retiro del candado, checklist solo de práctica.</a:t>
+              <a:t>Vetó las dos misiones. Alturas: 19 hallazgos y 2 de seguimiento (queda 1 mejora menor). LOTO y documentos: 14 y 5, todos cerrados: energía cero completa, retiro del candado, checklist solo de práctica.</a:t>
             </a:r>
           </a:p>
         </p:txBody>
@@ -15833,8 +15833,8 @@
         </p:nvSpPr>
         <p:spPr>
           <a:xfrm>
-            <a:off x="658368" y="3849624"/>
-            <a:ext cx="10874959" cy="676656"/>
+            <a:off x="658368" y="3922776"/>
+            <a:ext cx="10874959" cy="566928"/>
           </a:xfrm>
           <a:prstGeom prst="rect">
             <a:avLst/>
@@ -15879,8 +15879,8 @@
         </p:nvSpPr>
         <p:spPr>
           <a:xfrm>
-            <a:off x="841247" y="3849624"/>
-            <a:ext cx="2148839" cy="676656"/>
+            <a:off x="841247" y="3922776"/>
+            <a:ext cx="2148839" cy="566928"/>
           </a:xfrm>
           <a:prstGeom prst="rect">
             <a:avLst/>
@@ -15918,7 +15918,7 @@
         </p:nvSpPr>
         <p:spPr>
           <a:xfrm>
-            <a:off x="3172968" y="4123944"/>
+            <a:off x="3172968" y="4142231"/>
             <a:ext cx="128016" cy="128016"/>
           </a:xfrm>
           <a:prstGeom prst="ellipse">
@@ -15962,8 +15962,8 @@
         </p:nvSpPr>
         <p:spPr>
           <a:xfrm>
-            <a:off x="3392424" y="3849624"/>
-            <a:ext cx="2560320" cy="676656"/>
+            <a:off x="3392424" y="3922776"/>
+            <a:ext cx="2560320" cy="566928"/>
           </a:xfrm>
           <a:prstGeom prst="rect">
             <a:avLst/>
@@ -15982,7 +15982,7 @@
               </a:lnSpc>
             </a:pPr>
             <a:r>
-              <a:rPr sz="1100" b="1" i="0">
+              <a:rPr sz="1050" b="1" i="0">
                 <a:solidFill>
                   <a:srgbClr val="2B3340"/>
                 </a:solidFill>
@@ -16001,8 +16001,8 @@
         </p:nvSpPr>
         <p:spPr>
           <a:xfrm>
-            <a:off x="6053327" y="3849624"/>
-            <a:ext cx="5297119" cy="676656"/>
+            <a:off x="6053327" y="3922776"/>
+            <a:ext cx="5297119" cy="566928"/>
           </a:xfrm>
           <a:prstGeom prst="rect">
             <a:avLst/>
@@ -16040,8 +16040,8 @@
         </p:nvSpPr>
         <p:spPr>
           <a:xfrm>
-            <a:off x="658368" y="4581144"/>
-            <a:ext cx="10874959" cy="676656"/>
+            <a:off x="658368" y="4535424"/>
+            <a:ext cx="10874959" cy="786384"/>
           </a:xfrm>
           <a:prstGeom prst="rect">
             <a:avLst/>
@@ -16086,8 +16086,8 @@
         </p:nvSpPr>
         <p:spPr>
           <a:xfrm>
-            <a:off x="841247" y="4581144"/>
-            <a:ext cx="2148839" cy="676656"/>
+            <a:off x="841247" y="4535424"/>
+            <a:ext cx="2148839" cy="786384"/>
           </a:xfrm>
           <a:prstGeom prst="rect">
             <a:avLst/>
@@ -16125,7 +16125,7 @@
         </p:nvSpPr>
         <p:spPr>
           <a:xfrm>
-            <a:off x="3172968" y="4855464"/>
+            <a:off x="3172968" y="4864607"/>
             <a:ext cx="128016" cy="128016"/>
           </a:xfrm>
           <a:prstGeom prst="ellipse">
@@ -16169,8 +16169,8 @@
         </p:nvSpPr>
         <p:spPr>
           <a:xfrm>
-            <a:off x="3392424" y="4581144"/>
-            <a:ext cx="2560320" cy="676656"/>
+            <a:off x="3392424" y="4535424"/>
+            <a:ext cx="2560320" cy="786384"/>
           </a:xfrm>
           <a:prstGeom prst="rect">
             <a:avLst/>
@@ -16189,13 +16189,13 @@
               </a:lnSpc>
             </a:pPr>
             <a:r>
-              <a:rPr sz="1100" b="1" i="0">
+              <a:rPr sz="1050" b="1" i="0">
                 <a:solidFill>
                   <a:srgbClr val="2B3340"/>
                 </a:solidFill>
                 <a:latin typeface="Segoe UI"/>
               </a:rPr>
-              <a:t>Validado · solo personal de confianza</a:t>
+              <a:t>Validado con cambios para personal de confianza · sindicalizados: pendiente CMCAP y Jurídico Laboral</a:t>
             </a:r>
           </a:p>
         </p:txBody>
@@ -16208,8 +16208,8 @@
         </p:nvSpPr>
         <p:spPr>
           <a:xfrm>
-            <a:off x="6053327" y="4581144"/>
-            <a:ext cx="5297119" cy="676656"/>
+            <a:off x="6053327" y="4535424"/>
+            <a:ext cx="5297119" cy="786384"/>
           </a:xfrm>
           <a:prstGeom prst="rect">
             <a:avLst/>
@@ -16234,7 +16234,7 @@
                 </a:solidFill>
                 <a:latin typeface="Segoe UI"/>
               </a:rPr>
-              <a:t>14 cambios: aviso de no uso, firmas de práctica sin nombre real, canal alterno a Seguridad Industrial y borrado completo de datos.</a:t>
+              <a:t>14 cambios: aviso de no uso, firmas de práctica sin nombre real, canal alterno a Seguridad Industrial, borrado completo de datos y nuevo ingreso sindicalizable fuera del piloto.</a:t>
             </a:r>
           </a:p>
         </p:txBody>
@@ -16247,8 +16247,8 @@
         </p:nvSpPr>
         <p:spPr>
           <a:xfrm>
-            <a:off x="658368" y="5312664"/>
-            <a:ext cx="10874959" cy="676656"/>
+            <a:off x="658368" y="5367528"/>
+            <a:ext cx="10874959" cy="420624"/>
           </a:xfrm>
           <a:prstGeom prst="rect">
             <a:avLst/>
@@ -16293,8 +16293,8 @@
         </p:nvSpPr>
         <p:spPr>
           <a:xfrm>
-            <a:off x="841247" y="5312664"/>
-            <a:ext cx="2148839" cy="676656"/>
+            <a:off x="841247" y="5367528"/>
+            <a:ext cx="2148839" cy="420624"/>
           </a:xfrm>
           <a:prstGeom prst="rect">
             <a:avLst/>
@@ -16332,7 +16332,7 @@
         </p:nvSpPr>
         <p:spPr>
           <a:xfrm>
-            <a:off x="3172968" y="5586984"/>
+            <a:off x="3172968" y="5513832"/>
             <a:ext cx="128016" cy="128016"/>
           </a:xfrm>
           <a:prstGeom prst="ellipse">
@@ -16376,8 +16376,8 @@
         </p:nvSpPr>
         <p:spPr>
           <a:xfrm>
-            <a:off x="3392424" y="5312664"/>
-            <a:ext cx="2560320" cy="676656"/>
+            <a:off x="3392424" y="5367528"/>
+            <a:ext cx="2560320" cy="420624"/>
           </a:xfrm>
           <a:prstGeom prst="rect">
             <a:avLst/>
@@ -16396,7 +16396,7 @@
               </a:lnSpc>
             </a:pPr>
             <a:r>
-              <a:rPr sz="1100" b="1" i="0">
+              <a:rPr sz="1050" b="1" i="0">
                 <a:solidFill>
                   <a:srgbClr val="2B3340"/>
                 </a:solidFill>
@@ -16415,8 +16415,8 @@
         </p:nvSpPr>
         <p:spPr>
           <a:xfrm>
-            <a:off x="6053327" y="5312664"/>
-            <a:ext cx="5297119" cy="676656"/>
+            <a:off x="6053327" y="5367528"/>
+            <a:ext cx="5297119" cy="420624"/>
           </a:xfrm>
           <a:prstGeom prst="rect">
             <a:avLst/>
@@ -17532,7 +17532,7 @@
                 </a:solidFill>
                 <a:latin typeface="Segoe UI"/>
               </a:rPr>
-              <a:t>No es constancia DC-3 ni examen de suficiencia. La competencia la evalúa un evaluador autorizado en piso.</a:t>
+              <a:t>No es constancia DC-3 ni examen de suficiencia o de escalafón. La autorización y la evaluación de competencia las otorga la planta (Seguridad).</a:t>
             </a:r>
           </a:p>
         </p:txBody>
@@ -17791,7 +17791,7 @@
                 </a:solidFill>
                 <a:latin typeface="Segoe UI"/>
               </a:rPr>
-              <a:t>No se usa para escalafón, ascensos, cambios de puesto o de categoría, desempeño, sanciones ni bonos.</a:t>
+              <a:t>Ni la práctica ni el avance se usan para escalafón, ascensos, cambios de puesto o de categoría, evaluación de desempeño, sanciones ni bonos.</a:t>
             </a:r>
           </a:p>
         </p:txBody>
@@ -18050,7 +18050,7 @@
                 </a:solidFill>
                 <a:latin typeface="Segoe UI"/>
               </a:rPr>
-              <a:t>Sin nombre ni número de ficha. Los datos se quedan en el equipo y se borran con un botón.</a:t>
+              <a:t>Sin nombre ni número de ficha. En esta fase, los datos se quedan en el equipo, se analizan solo por grupo y se borran con un botón.</a:t>
             </a:r>
           </a:p>
         </p:txBody>
@@ -18826,14 +18826,14 @@
           <a:p>
             <a:pPr>
               <a:lnSpc>
-                <a:spcPct val="108000"/>
+                <a:spcPct val="106000"/>
               </a:lnSpc>
               <a:spcAft>
-                <a:spcPts val="800"/>
+                <a:spcPts val="600"/>
               </a:spcAft>
             </a:pPr>
             <a:r>
-              <a:rPr sz="1150" b="1" i="0">
+              <a:rPr sz="1100" b="1" i="0">
                 <a:solidFill>
                   <a:srgbClr val="C2993D"/>
                 </a:solidFill>
@@ -18842,7 +18842,7 @@
               <a:t>▪  </a:t>
             </a:r>
             <a:r>
-              <a:rPr sz="1150" b="0" i="0">
+              <a:rPr sz="1100" b="0" i="0">
                 <a:solidFill>
                   <a:srgbClr val="E4EAF4"/>
                 </a:solidFill>
@@ -18854,14 +18854,14 @@
           <a:p>
             <a:pPr>
               <a:lnSpc>
-                <a:spcPct val="108000"/>
+                <a:spcPct val="106000"/>
               </a:lnSpc>
               <a:spcAft>
-                <a:spcPts val="800"/>
+                <a:spcPts val="600"/>
               </a:spcAft>
             </a:pPr>
             <a:r>
-              <a:rPr sz="1150" b="1" i="0">
+              <a:rPr sz="1100" b="1" i="0">
                 <a:solidFill>
                   <a:srgbClr val="C2993D"/>
                 </a:solidFill>
@@ -18870,7 +18870,7 @@
               <a:t>▪  </a:t>
             </a:r>
             <a:r>
-              <a:rPr sz="1150" b="0" i="0">
+              <a:rPr sz="1100" b="0" i="0">
                 <a:solidFill>
                   <a:srgbClr val="E4EAF4"/>
                 </a:solidFill>
@@ -18882,14 +18882,14 @@
           <a:p>
             <a:pPr>
               <a:lnSpc>
-                <a:spcPct val="108000"/>
+                <a:spcPct val="106000"/>
               </a:lnSpc>
               <a:spcAft>
-                <a:spcPts val="800"/>
+                <a:spcPts val="600"/>
               </a:spcAft>
             </a:pPr>
             <a:r>
-              <a:rPr sz="1150" b="1" i="0">
+              <a:rPr sz="1100" b="1" i="0">
                 <a:solidFill>
                   <a:srgbClr val="C2993D"/>
                 </a:solidFill>
@@ -18898,7 +18898,7 @@
               <a:t>▪  </a:t>
             </a:r>
             <a:r>
-              <a:rPr sz="1150" b="0" i="0">
+              <a:rPr sz="1100" b="0" i="0">
                 <a:solidFill>
                   <a:srgbClr val="E4EAF4"/>
                 </a:solidFill>
@@ -18910,14 +18910,14 @@
           <a:p>
             <a:pPr>
               <a:lnSpc>
-                <a:spcPct val="108000"/>
+                <a:spcPct val="106000"/>
               </a:lnSpc>
               <a:spcAft>
-                <a:spcPts val="800"/>
+                <a:spcPts val="600"/>
               </a:spcAft>
             </a:pPr>
             <a:r>
-              <a:rPr sz="1150" b="1" i="0">
+              <a:rPr sz="1100" b="1" i="0">
                 <a:solidFill>
                   <a:srgbClr val="C2993D"/>
                 </a:solidFill>
@@ -18926,26 +18926,54 @@
               <a:t>▪  </a:t>
             </a:r>
             <a:r>
-              <a:rPr sz="1150" b="0" i="0">
+              <a:rPr sz="1100" b="0" i="0">
                 <a:solidFill>
                   <a:srgbClr val="E4EAF4"/>
                 </a:solidFill>
                 <a:latin typeface="Segoe UI"/>
               </a:rPr>
+              <a:t>Participación voluntaria y dentro de la jornada; se evalúa la herramienta, no a la persona.</a:t>
+            </a:r>
+          </a:p>
+          <a:p>
+            <a:pPr>
+              <a:lnSpc>
+                <a:spcPct val="106000"/>
+              </a:lnSpc>
+              <a:spcAft>
+                <a:spcPts val="600"/>
+              </a:spcAft>
+            </a:pPr>
+            <a:r>
+              <a:rPr sz="1100" b="1" i="0">
+                <a:solidFill>
+                  <a:srgbClr val="C2993D"/>
+                </a:solidFill>
+                <a:latin typeface="Segoe UI"/>
+              </a:rPr>
+              <a:t>▪  </a:t>
+            </a:r>
+            <a:r>
+              <a:rPr sz="1100" b="0" i="0">
+                <a:solidFill>
+                  <a:srgbClr val="E4EAF4"/>
+                </a:solidFill>
+                <a:latin typeface="Segoe UI"/>
+              </a:rPr>
               <a:t>Los datos se borran frente a la persona al terminar.</a:t>
             </a:r>
           </a:p>
           <a:p>
             <a:pPr>
               <a:lnSpc>
-                <a:spcPct val="108000"/>
+                <a:spcPct val="106000"/>
               </a:lnSpc>
               <a:spcAft>
-                <a:spcPts val="800"/>
+                <a:spcPts val="600"/>
               </a:spcAft>
             </a:pPr>
             <a:r>
-              <a:rPr sz="1150" b="1" i="0">
+              <a:rPr sz="1100" b="1" i="0">
                 <a:solidFill>
                   <a:srgbClr val="C2993D"/>
                 </a:solidFill>
@@ -18954,7 +18982,7 @@
               <a:t>▪  </a:t>
             </a:r>
             <a:r>
-              <a:rPr sz="1150" b="0" i="0">
+              <a:rPr sz="1100" b="0" i="0">
                 <a:solidFill>
                   <a:srgbClr val="E4EAF4"/>
                 </a:solidFill>
@@ -20372,7 +20400,7 @@
         <p:spPr>
           <a:xfrm>
             <a:off x="1709928" y="1975104"/>
-            <a:ext cx="1706879" cy="1219200"/>
+            <a:ext cx="1432560" cy="1188720"/>
           </a:xfrm>
           <a:prstGeom prst="rect">
             <a:avLst/>
@@ -20417,8 +20445,8 @@
         </p:nvSpPr>
         <p:spPr>
           <a:xfrm>
-            <a:off x="3416807" y="1975104"/>
-            <a:ext cx="1706879" cy="1219200"/>
+            <a:off x="3142488" y="1975104"/>
+            <a:ext cx="1432560" cy="1188720"/>
           </a:xfrm>
           <a:prstGeom prst="rect">
             <a:avLst/>
@@ -20463,8 +20491,8 @@
         </p:nvSpPr>
         <p:spPr>
           <a:xfrm>
-            <a:off x="5123687" y="1975104"/>
-            <a:ext cx="1706879" cy="1219200"/>
+            <a:off x="4575048" y="1975104"/>
+            <a:ext cx="1432560" cy="1188720"/>
           </a:xfrm>
           <a:prstGeom prst="rect">
             <a:avLst/>
@@ -20509,8 +20537,8 @@
         </p:nvSpPr>
         <p:spPr>
           <a:xfrm>
-            <a:off x="1709928" y="3194304"/>
-            <a:ext cx="1706879" cy="1219200"/>
+            <a:off x="1709928" y="3163824"/>
+            <a:ext cx="1432560" cy="1188720"/>
           </a:xfrm>
           <a:prstGeom prst="rect">
             <a:avLst/>
@@ -20555,8 +20583,8 @@
         </p:nvSpPr>
         <p:spPr>
           <a:xfrm>
-            <a:off x="3416807" y="3194304"/>
-            <a:ext cx="1706879" cy="1219200"/>
+            <a:off x="3142488" y="3163824"/>
+            <a:ext cx="1432560" cy="1188720"/>
           </a:xfrm>
           <a:prstGeom prst="rect">
             <a:avLst/>
@@ -20601,8 +20629,8 @@
         </p:nvSpPr>
         <p:spPr>
           <a:xfrm>
-            <a:off x="5123687" y="3194304"/>
-            <a:ext cx="1706879" cy="1219200"/>
+            <a:off x="4575048" y="3163824"/>
+            <a:ext cx="1432560" cy="1188720"/>
           </a:xfrm>
           <a:prstGeom prst="rect">
             <a:avLst/>
@@ -20647,8 +20675,8 @@
         </p:nvSpPr>
         <p:spPr>
           <a:xfrm>
-            <a:off x="1709928" y="4413504"/>
-            <a:ext cx="1706879" cy="1219200"/>
+            <a:off x="1709928" y="4352544"/>
+            <a:ext cx="1432560" cy="1188720"/>
           </a:xfrm>
           <a:prstGeom prst="rect">
             <a:avLst/>
@@ -20693,8 +20721,8 @@
         </p:nvSpPr>
         <p:spPr>
           <a:xfrm>
-            <a:off x="3416807" y="4413504"/>
-            <a:ext cx="1706879" cy="1219200"/>
+            <a:off x="3142488" y="4352544"/>
+            <a:ext cx="1432560" cy="1188720"/>
           </a:xfrm>
           <a:prstGeom prst="rect">
             <a:avLst/>
@@ -20739,8 +20767,8 @@
         </p:nvSpPr>
         <p:spPr>
           <a:xfrm>
-            <a:off x="5123687" y="4413504"/>
-            <a:ext cx="1706879" cy="1219200"/>
+            <a:off x="4575048" y="4352544"/>
+            <a:ext cx="1432560" cy="1188720"/>
           </a:xfrm>
           <a:prstGeom prst="rect">
             <a:avLst/>
@@ -20786,7 +20814,7 @@
         <p:spPr>
           <a:xfrm rot="16200000">
             <a:off x="749807" y="1975104"/>
-            <a:ext cx="822960" cy="3657600"/>
+            <a:ext cx="822960" cy="3566160"/>
           </a:xfrm>
           <a:prstGeom prst="rect">
             <a:avLst/>
@@ -20825,7 +20853,7 @@
         <p:spPr>
           <a:xfrm>
             <a:off x="1024127" y="1975104"/>
-            <a:ext cx="640080" cy="1219200"/>
+            <a:ext cx="640080" cy="1188720"/>
           </a:xfrm>
           <a:prstGeom prst="rect">
             <a:avLst/>
@@ -20863,8 +20891,8 @@
         </p:nvSpPr>
         <p:spPr>
           <a:xfrm>
-            <a:off x="1024127" y="3194304"/>
-            <a:ext cx="640080" cy="1219200"/>
+            <a:off x="1024127" y="3163824"/>
+            <a:ext cx="640080" cy="1188720"/>
           </a:xfrm>
           <a:prstGeom prst="rect">
             <a:avLst/>
@@ -20902,8 +20930,8 @@
         </p:nvSpPr>
         <p:spPr>
           <a:xfrm>
-            <a:off x="1024127" y="4413504"/>
-            <a:ext cx="640080" cy="1219200"/>
+            <a:off x="1024127" y="4352544"/>
+            <a:ext cx="640080" cy="1188720"/>
           </a:xfrm>
           <a:prstGeom prst="rect">
             <a:avLst/>
@@ -20941,8 +20969,8 @@
         </p:nvSpPr>
         <p:spPr>
           <a:xfrm>
-            <a:off x="1709928" y="5907024"/>
-            <a:ext cx="5120640" cy="274320"/>
+            <a:off x="1709928" y="5815584"/>
+            <a:ext cx="4297680" cy="274320"/>
           </a:xfrm>
           <a:prstGeom prst="rect">
             <a:avLst/>
@@ -20980,8 +21008,8 @@
         </p:nvSpPr>
         <p:spPr>
           <a:xfrm>
-            <a:off x="1709928" y="5669280"/>
-            <a:ext cx="1706879" cy="237744"/>
+            <a:off x="1709928" y="5577840"/>
+            <a:ext cx="1432560" cy="237744"/>
           </a:xfrm>
           <a:prstGeom prst="rect">
             <a:avLst/>
@@ -21019,8 +21047,8 @@
         </p:nvSpPr>
         <p:spPr>
           <a:xfrm>
-            <a:off x="3416807" y="5669280"/>
-            <a:ext cx="1706879" cy="237744"/>
+            <a:off x="3142488" y="5577840"/>
+            <a:ext cx="1432560" cy="237744"/>
           </a:xfrm>
           <a:prstGeom prst="rect">
             <a:avLst/>
@@ -21058,8 +21086,8 @@
         </p:nvSpPr>
         <p:spPr>
           <a:xfrm>
-            <a:off x="5123687" y="5669280"/>
-            <a:ext cx="1706879" cy="237744"/>
+            <a:off x="4575048" y="5577840"/>
+            <a:ext cx="1432560" cy="237744"/>
           </a:xfrm>
           <a:prstGeom prst="rect">
             <a:avLst/>
@@ -21097,8 +21125,8 @@
         </p:nvSpPr>
         <p:spPr>
           <a:xfrm>
-            <a:off x="4059935" y="2374392"/>
-            <a:ext cx="420624" cy="420624"/>
+            <a:off x="3666744" y="2377440"/>
+            <a:ext cx="384048" cy="384048"/>
           </a:xfrm>
           <a:prstGeom prst="ellipse">
             <a:avLst/>
@@ -21143,8 +21171,8 @@
         </p:nvSpPr>
         <p:spPr>
           <a:xfrm>
-            <a:off x="4059935" y="2365248"/>
-            <a:ext cx="420624" cy="420624"/>
+            <a:off x="3666744" y="2368296"/>
+            <a:ext cx="384048" cy="384048"/>
           </a:xfrm>
           <a:prstGeom prst="rect">
             <a:avLst/>
@@ -21182,8 +21210,8 @@
         </p:nvSpPr>
         <p:spPr>
           <a:xfrm>
-            <a:off x="2353056" y="2374392"/>
-            <a:ext cx="420624" cy="420624"/>
+            <a:off x="2005584" y="2377440"/>
+            <a:ext cx="384048" cy="384048"/>
           </a:xfrm>
           <a:prstGeom prst="ellipse">
             <a:avLst/>
@@ -21228,8 +21256,8 @@
         </p:nvSpPr>
         <p:spPr>
           <a:xfrm>
-            <a:off x="2353056" y="2365248"/>
-            <a:ext cx="420624" cy="420624"/>
+            <a:off x="2005584" y="2368296"/>
+            <a:ext cx="384048" cy="384048"/>
           </a:xfrm>
           <a:prstGeom prst="rect">
             <a:avLst/>
@@ -21267,8 +21295,8 @@
         </p:nvSpPr>
         <p:spPr>
           <a:xfrm>
-            <a:off x="3813048" y="3593592"/>
-            <a:ext cx="420624" cy="420624"/>
+            <a:off x="2462784" y="2377440"/>
+            <a:ext cx="384048" cy="384048"/>
           </a:xfrm>
           <a:prstGeom prst="ellipse">
             <a:avLst/>
@@ -21313,8 +21341,8 @@
         </p:nvSpPr>
         <p:spPr>
           <a:xfrm>
-            <a:off x="3813048" y="3584448"/>
-            <a:ext cx="420624" cy="420624"/>
+            <a:off x="2462784" y="2368296"/>
+            <a:ext cx="384048" cy="384048"/>
           </a:xfrm>
           <a:prstGeom prst="rect">
             <a:avLst/>
@@ -21339,7 +21367,7 @@
                 </a:solidFill>
                 <a:latin typeface="Segoe UI Semibold"/>
               </a:rPr>
-              <a:t>R3</a:t>
+              <a:t>R7</a:t>
             </a:r>
           </a:p>
         </p:txBody>
@@ -21352,8 +21380,8 @@
         </p:nvSpPr>
         <p:spPr>
           <a:xfrm>
-            <a:off x="4306823" y="3593592"/>
-            <a:ext cx="420624" cy="420624"/>
+            <a:off x="3438144" y="3566160"/>
+            <a:ext cx="384048" cy="384048"/>
           </a:xfrm>
           <a:prstGeom prst="ellipse">
             <a:avLst/>
@@ -21398,8 +21426,8 @@
         </p:nvSpPr>
         <p:spPr>
           <a:xfrm>
-            <a:off x="4306823" y="3584448"/>
-            <a:ext cx="420624" cy="420624"/>
+            <a:off x="3438144" y="3557016"/>
+            <a:ext cx="384048" cy="384048"/>
           </a:xfrm>
           <a:prstGeom prst="rect">
             <a:avLst/>
@@ -21424,7 +21452,7 @@
                 </a:solidFill>
                 <a:latin typeface="Segoe UI Semibold"/>
               </a:rPr>
-              <a:t>R6</a:t>
+              <a:t>R3</a:t>
             </a:r>
           </a:p>
         </p:txBody>
@@ -21437,8 +21465,8 @@
         </p:nvSpPr>
         <p:spPr>
           <a:xfrm>
-            <a:off x="5766815" y="3593592"/>
-            <a:ext cx="420624" cy="420624"/>
+            <a:off x="3895344" y="3566160"/>
+            <a:ext cx="384048" cy="384048"/>
           </a:xfrm>
           <a:prstGeom prst="ellipse">
             <a:avLst/>
@@ -21483,8 +21511,8 @@
         </p:nvSpPr>
         <p:spPr>
           <a:xfrm>
-            <a:off x="5766815" y="3584448"/>
-            <a:ext cx="420624" cy="420624"/>
+            <a:off x="3895344" y="3557016"/>
+            <a:ext cx="384048" cy="384048"/>
           </a:xfrm>
           <a:prstGeom prst="rect">
             <a:avLst/>
@@ -21509,7 +21537,7 @@
                 </a:solidFill>
                 <a:latin typeface="Segoe UI Semibold"/>
               </a:rPr>
-              <a:t>R4</a:t>
+              <a:t>R6</a:t>
             </a:r>
           </a:p>
         </p:txBody>
@@ -21522,8 +21550,8 @@
         </p:nvSpPr>
         <p:spPr>
           <a:xfrm>
-            <a:off x="4059935" y="4812791"/>
-            <a:ext cx="420624" cy="420624"/>
+            <a:off x="5099304" y="3566160"/>
+            <a:ext cx="384048" cy="384048"/>
           </a:xfrm>
           <a:prstGeom prst="ellipse">
             <a:avLst/>
@@ -21568,8 +21596,8 @@
         </p:nvSpPr>
         <p:spPr>
           <a:xfrm>
-            <a:off x="4059935" y="4803648"/>
-            <a:ext cx="420624" cy="420624"/>
+            <a:off x="5099304" y="3557016"/>
+            <a:ext cx="384048" cy="384048"/>
           </a:xfrm>
           <a:prstGeom prst="rect">
             <a:avLst/>
@@ -21594,6 +21622,91 @@
                 </a:solidFill>
                 <a:latin typeface="Segoe UI Semibold"/>
               </a:rPr>
+              <a:t>R4</a:t>
+            </a:r>
+          </a:p>
+        </p:txBody>
+      </p:sp>
+      <p:sp>
+        <p:nvSpPr>
+          <p:cNvPr id="36" name="Oval 35"/>
+          <p:cNvSpPr/>
+          <p:nvPr/>
+        </p:nvSpPr>
+        <p:spPr>
+          <a:xfrm>
+            <a:off x="3666744" y="4754880"/>
+            <a:ext cx="384048" cy="384048"/>
+          </a:xfrm>
+          <a:prstGeom prst="ellipse">
+            <a:avLst/>
+          </a:prstGeom>
+          <a:solidFill>
+            <a:srgbClr val="1F3864"/>
+          </a:solidFill>
+          <a:ln w="19050">
+            <a:solidFill>
+              <a:srgbClr val="FFFFFF"/>
+            </a:solidFill>
+          </a:ln>
+          <a:effectLst/>
+        </p:spPr>
+        <p:style>
+          <a:lnRef idx="1">
+            <a:schemeClr val="accent1"/>
+          </a:lnRef>
+          <a:fillRef idx="3">
+            <a:schemeClr val="accent1"/>
+          </a:fillRef>
+          <a:effectRef idx="2">
+            <a:schemeClr val="accent1"/>
+          </a:effectRef>
+          <a:fontRef idx="minor">
+            <a:schemeClr val="lt1"/>
+          </a:fontRef>
+        </p:style>
+        <p:txBody>
+          <a:bodyPr rtlCol="0" anchor="ctr"/>
+          <a:lstStyle/>
+          <a:p>
+            <a:pPr algn="ctr"/>
+          </a:p>
+        </p:txBody>
+      </p:sp>
+      <p:sp>
+        <p:nvSpPr>
+          <p:cNvPr id="37" name="TextBox 36"/>
+          <p:cNvSpPr txBox="1"/>
+          <p:nvPr/>
+        </p:nvSpPr>
+        <p:spPr>
+          <a:xfrm>
+            <a:off x="3666744" y="4745736"/>
+            <a:ext cx="384048" cy="384048"/>
+          </a:xfrm>
+          <a:prstGeom prst="rect">
+            <a:avLst/>
+          </a:prstGeom>
+          <a:noFill/>
+        </p:spPr>
+        <p:txBody>
+          <a:bodyPr wrap="square" anchor="ctr" lIns="0" rIns="0" tIns="0" bIns="0">
+            <a:spAutoFit/>
+          </a:bodyPr>
+          <a:lstStyle/>
+          <a:p>
+            <a:pPr algn="ctr">
+              <a:lnSpc>
+                <a:spcPct val="100000"/>
+              </a:lnSpc>
+            </a:pPr>
+            <a:r>
+              <a:rPr sz="900" b="1" i="0">
+                <a:solidFill>
+                  <a:srgbClr val="FFFFFF"/>
+                </a:solidFill>
+                <a:latin typeface="Segoe UI Semibold"/>
+              </a:rPr>
               <a:t>R5</a:t>
             </a:r>
           </a:p>
@@ -21601,14 +21714,14 @@
       </p:sp>
       <p:sp>
         <p:nvSpPr>
-          <p:cNvPr id="36" name="TextBox 35"/>
-          <p:cNvSpPr txBox="1"/>
-          <p:nvPr/>
-        </p:nvSpPr>
-        <p:spPr>
-          <a:xfrm>
-            <a:off x="7287768" y="1938528"/>
-            <a:ext cx="4245559" cy="274320"/>
+          <p:cNvPr id="38" name="TextBox 37"/>
+          <p:cNvSpPr txBox="1"/>
+          <p:nvPr/>
+        </p:nvSpPr>
+        <p:spPr>
+          <a:xfrm>
+            <a:off x="6419088" y="1883664"/>
+            <a:ext cx="5114239" cy="274320"/>
           </a:xfrm>
           <a:prstGeom prst="rect">
             <a:avLst/>
@@ -21640,14 +21753,14 @@
       </p:sp>
       <p:sp>
         <p:nvSpPr>
-          <p:cNvPr id="37" name="TextBox 36"/>
-          <p:cNvSpPr txBox="1"/>
-          <p:nvPr/>
-        </p:nvSpPr>
-        <p:spPr>
-          <a:xfrm>
-            <a:off x="7287768" y="2286000"/>
-            <a:ext cx="457200" cy="274320"/>
+          <p:cNvPr id="39" name="TextBox 38"/>
+          <p:cNvSpPr txBox="1"/>
+          <p:nvPr/>
+        </p:nvSpPr>
+        <p:spPr>
+          <a:xfrm>
+            <a:off x="6419088" y="2231136"/>
+            <a:ext cx="411480" cy="228600"/>
           </a:xfrm>
           <a:prstGeom prst="rect">
             <a:avLst/>
@@ -21666,7 +21779,7 @@
               </a:lnSpc>
             </a:pPr>
             <a:r>
-              <a:rPr sz="1050" b="1" i="0">
+              <a:rPr sz="1000" b="1" i="0">
                 <a:solidFill>
                   <a:srgbClr val="1F3864"/>
                 </a:solidFill>
@@ -21679,14 +21792,14 @@
       </p:sp>
       <p:sp>
         <p:nvSpPr>
-          <p:cNvPr id="38" name="TextBox 37"/>
-          <p:cNvSpPr txBox="1"/>
-          <p:nvPr/>
-        </p:nvSpPr>
-        <p:spPr>
-          <a:xfrm>
-            <a:off x="7744967" y="2286000"/>
-            <a:ext cx="3788359" cy="274320"/>
+          <p:cNvPr id="40" name="TextBox 39"/>
+          <p:cNvSpPr txBox="1"/>
+          <p:nvPr/>
+        </p:nvSpPr>
+        <p:spPr>
+          <a:xfrm>
+            <a:off x="6830568" y="2231136"/>
+            <a:ext cx="4702759" cy="329184"/>
           </a:xfrm>
           <a:prstGeom prst="rect">
             <a:avLst/>
@@ -21705,27 +21818,27 @@
               </a:lnSpc>
             </a:pPr>
             <a:r>
-              <a:rPr sz="1050" b="1" i="0">
+              <a:rPr sz="1000" b="1" i="0">
                 <a:solidFill>
                   <a:srgbClr val="2B3340"/>
                 </a:solidFill>
                 <a:latin typeface="Segoe UI"/>
               </a:rPr>
-              <a:t>Confundir la práctica con un procedimiento</a:t>
-            </a:r>
-          </a:p>
-        </p:txBody>
-      </p:sp>
-      <p:sp>
-        <p:nvSpPr>
-          <p:cNvPr id="39" name="TextBox 38"/>
-          <p:cNvSpPr txBox="1"/>
-          <p:nvPr/>
-        </p:nvSpPr>
-        <p:spPr>
-          <a:xfrm>
-            <a:off x="7744967" y="2569464"/>
-            <a:ext cx="3788359" cy="274320"/>
+              <a:t>Confundir la práctica con un procedimiento o con una autorización</a:t>
+            </a:r>
+          </a:p>
+        </p:txBody>
+      </p:sp>
+      <p:sp>
+        <p:nvSpPr>
+          <p:cNvPr id="41" name="TextBox 40"/>
+          <p:cNvSpPr txBox="1"/>
+          <p:nvPr/>
+        </p:nvSpPr>
+        <p:spPr>
+          <a:xfrm>
+            <a:off x="6830568" y="2578608"/>
+            <a:ext cx="4702759" cy="155448"/>
           </a:xfrm>
           <a:prstGeom prst="rect">
             <a:avLst/>
@@ -21744,27 +21857,27 @@
               </a:lnSpc>
             </a:pPr>
             <a:r>
-              <a:rPr sz="1000" b="0" i="0">
+              <a:rPr sz="950" b="0" i="0">
                 <a:solidFill>
                   <a:srgbClr val="535E6E"/>
                 </a:solidFill>
                 <a:latin typeface="Segoe UI"/>
               </a:rPr>
-              <a:t>→ Aviso DEMO, guion y criterio de paro.</a:t>
-            </a:r>
-          </a:p>
-        </p:txBody>
-      </p:sp>
-      <p:sp>
-        <p:nvSpPr>
-          <p:cNvPr id="40" name="TextBox 39"/>
-          <p:cNvSpPr txBox="1"/>
-          <p:nvPr/>
-        </p:nvSpPr>
-        <p:spPr>
-          <a:xfrm>
-            <a:off x="7287768" y="2944368"/>
-            <a:ext cx="457200" cy="274320"/>
+              <a:t>→ Aviso DEMO, guion del instructor y criterio de paro.</a:t>
+            </a:r>
+          </a:p>
+        </p:txBody>
+      </p:sp>
+      <p:sp>
+        <p:nvSpPr>
+          <p:cNvPr id="42" name="TextBox 41"/>
+          <p:cNvSpPr txBox="1"/>
+          <p:nvPr/>
+        </p:nvSpPr>
+        <p:spPr>
+          <a:xfrm>
+            <a:off x="6419088" y="2843784"/>
+            <a:ext cx="411480" cy="228600"/>
           </a:xfrm>
           <a:prstGeom prst="rect">
             <a:avLst/>
@@ -21783,7 +21896,7 @@
               </a:lnSpc>
             </a:pPr>
             <a:r>
-              <a:rPr sz="1050" b="1" i="0">
+              <a:rPr sz="1000" b="1" i="0">
                 <a:solidFill>
                   <a:srgbClr val="1F3864"/>
                 </a:solidFill>
@@ -21796,14 +21909,14 @@
       </p:sp>
       <p:sp>
         <p:nvSpPr>
-          <p:cNvPr id="41" name="TextBox 40"/>
-          <p:cNvSpPr txBox="1"/>
-          <p:nvPr/>
-        </p:nvSpPr>
-        <p:spPr>
-          <a:xfrm>
-            <a:off x="7744967" y="2944368"/>
-            <a:ext cx="3788359" cy="274320"/>
+          <p:cNvPr id="43" name="TextBox 42"/>
+          <p:cNvSpPr txBox="1"/>
+          <p:nvPr/>
+        </p:nvSpPr>
+        <p:spPr>
+          <a:xfrm>
+            <a:off x="6830568" y="2843784"/>
+            <a:ext cx="4702759" cy="164592"/>
           </a:xfrm>
           <a:prstGeom prst="rect">
             <a:avLst/>
@@ -21822,27 +21935,27 @@
               </a:lnSpc>
             </a:pPr>
             <a:r>
-              <a:rPr sz="1050" b="1" i="0">
+              <a:rPr sz="1000" b="1" i="0">
                 <a:solidFill>
                   <a:srgbClr val="2B3340"/>
                 </a:solidFill>
                 <a:latin typeface="Segoe UI"/>
               </a:rPr>
-              <a:t>Entra personal sindicalizable sin la CMCAP</a:t>
-            </a:r>
-          </a:p>
-        </p:txBody>
-      </p:sp>
-      <p:sp>
-        <p:nvSpPr>
-          <p:cNvPr id="42" name="TextBox 41"/>
-          <p:cNvSpPr txBox="1"/>
-          <p:nvPr/>
-        </p:nvSpPr>
-        <p:spPr>
-          <a:xfrm>
-            <a:off x="7744967" y="3227832"/>
-            <a:ext cx="3788359" cy="274320"/>
+              <a:t>Entra personal sindicalizable sin acuerdo de la CMCAP</a:t>
+            </a:r>
+          </a:p>
+        </p:txBody>
+      </p:sp>
+      <p:sp>
+        <p:nvSpPr>
+          <p:cNvPr id="44" name="TextBox 43"/>
+          <p:cNvSpPr txBox="1"/>
+          <p:nvPr/>
+        </p:nvSpPr>
+        <p:spPr>
+          <a:xfrm>
+            <a:off x="6830568" y="3026664"/>
+            <a:ext cx="4702759" cy="155448"/>
           </a:xfrm>
           <a:prstGeom prst="rect">
             <a:avLst/>
@@ -21861,27 +21974,27 @@
               </a:lnSpc>
             </a:pPr>
             <a:r>
-              <a:rPr sz="1000" b="0" i="0">
+              <a:rPr sz="950" b="0" i="0">
                 <a:solidFill>
                   <a:srgbClr val="535E6E"/>
                 </a:solidFill>
                 <a:latin typeface="Segoe UI"/>
               </a:rPr>
-              <a:t>→ Filtro por puesto con Relaciones Laborales.</a:t>
-            </a:r>
-          </a:p>
-        </p:txBody>
-      </p:sp>
-      <p:sp>
-        <p:nvSpPr>
-          <p:cNvPr id="43" name="TextBox 42"/>
-          <p:cNvSpPr txBox="1"/>
-          <p:nvPr/>
-        </p:nvSpPr>
-        <p:spPr>
-          <a:xfrm>
-            <a:off x="7287768" y="3602735"/>
-            <a:ext cx="457200" cy="274320"/>
+              <a:t>→ Filtro por puesto con visto bueno de Relaciones Laborales.</a:t>
+            </a:r>
+          </a:p>
+        </p:txBody>
+      </p:sp>
+      <p:sp>
+        <p:nvSpPr>
+          <p:cNvPr id="45" name="TextBox 44"/>
+          <p:cNvSpPr txBox="1"/>
+          <p:nvPr/>
+        </p:nvSpPr>
+        <p:spPr>
+          <a:xfrm>
+            <a:off x="6419088" y="3291839"/>
+            <a:ext cx="411480" cy="228600"/>
           </a:xfrm>
           <a:prstGeom prst="rect">
             <a:avLst/>
@@ -21900,7 +22013,7 @@
               </a:lnSpc>
             </a:pPr>
             <a:r>
-              <a:rPr sz="1050" b="1" i="0">
+              <a:rPr sz="1000" b="1" i="0">
                 <a:solidFill>
                   <a:srgbClr val="1F3864"/>
                 </a:solidFill>
@@ -21913,14 +22026,14 @@
       </p:sp>
       <p:sp>
         <p:nvSpPr>
-          <p:cNvPr id="44" name="TextBox 43"/>
-          <p:cNvSpPr txBox="1"/>
-          <p:nvPr/>
-        </p:nvSpPr>
-        <p:spPr>
-          <a:xfrm>
-            <a:off x="7744967" y="3602735"/>
-            <a:ext cx="3788359" cy="274320"/>
+          <p:cNvPr id="46" name="TextBox 45"/>
+          <p:cNvSpPr txBox="1"/>
+          <p:nvPr/>
+        </p:nvSpPr>
+        <p:spPr>
+          <a:xfrm>
+            <a:off x="6830568" y="3291839"/>
+            <a:ext cx="4702759" cy="164592"/>
           </a:xfrm>
           <a:prstGeom prst="rect">
             <a:avLst/>
@@ -21939,7 +22052,7 @@
               </a:lnSpc>
             </a:pPr>
             <a:r>
-              <a:rPr sz="1050" b="1" i="0">
+              <a:rPr sz="1000" b="1" i="0">
                 <a:solidFill>
                   <a:srgbClr val="2B3340"/>
                 </a:solidFill>
@@ -21952,14 +22065,14 @@
       </p:sp>
       <p:sp>
         <p:nvSpPr>
-          <p:cNvPr id="45" name="TextBox 44"/>
-          <p:cNvSpPr txBox="1"/>
-          <p:nvPr/>
-        </p:nvSpPr>
-        <p:spPr>
-          <a:xfrm>
-            <a:off x="7744967" y="3886199"/>
-            <a:ext cx="3788359" cy="274320"/>
+          <p:cNvPr id="47" name="TextBox 46"/>
+          <p:cNvSpPr txBox="1"/>
+          <p:nvPr/>
+        </p:nvSpPr>
+        <p:spPr>
+          <a:xfrm>
+            <a:off x="6830568" y="3474720"/>
+            <a:ext cx="4702759" cy="155448"/>
           </a:xfrm>
           <a:prstGeom prst="rect">
             <a:avLst/>
@@ -21978,27 +22091,27 @@
               </a:lnSpc>
             </a:pPr>
             <a:r>
-              <a:rPr sz="1000" b="0" i="0">
+              <a:rPr sz="950" b="0" i="0">
                 <a:solidFill>
                   <a:srgbClr val="535E6E"/>
                 </a:solidFill>
                 <a:latin typeface="Segoe UI"/>
               </a:rPr>
-              <a:t>→ Sin supervisor, sin nombres y con borrado.</a:t>
-            </a:r>
-          </a:p>
-        </p:txBody>
-      </p:sp>
-      <p:sp>
-        <p:nvSpPr>
-          <p:cNvPr id="46" name="TextBox 45"/>
-          <p:cNvSpPr txBox="1"/>
-          <p:nvPr/>
-        </p:nvSpPr>
-        <p:spPr>
-          <a:xfrm>
-            <a:off x="7287768" y="4261103"/>
-            <a:ext cx="457200" cy="274320"/>
+              <a:t>→ Sin supervisor, sin nombres y con borrado frente a la persona.</a:t>
+            </a:r>
+          </a:p>
+        </p:txBody>
+      </p:sp>
+      <p:sp>
+        <p:nvSpPr>
+          <p:cNvPr id="48" name="TextBox 47"/>
+          <p:cNvSpPr txBox="1"/>
+          <p:nvPr/>
+        </p:nvSpPr>
+        <p:spPr>
+          <a:xfrm>
+            <a:off x="6419088" y="3739896"/>
+            <a:ext cx="411480" cy="228600"/>
           </a:xfrm>
           <a:prstGeom prst="rect">
             <a:avLst/>
@@ -22017,7 +22130,7 @@
               </a:lnSpc>
             </a:pPr>
             <a:r>
-              <a:rPr sz="1050" b="1" i="0">
+              <a:rPr sz="1000" b="1" i="0">
                 <a:solidFill>
                   <a:srgbClr val="1F3864"/>
                 </a:solidFill>
@@ -22030,14 +22143,14 @@
       </p:sp>
       <p:sp>
         <p:nvSpPr>
-          <p:cNvPr id="47" name="TextBox 46"/>
-          <p:cNvSpPr txBox="1"/>
-          <p:nvPr/>
-        </p:nvSpPr>
-        <p:spPr>
-          <a:xfrm>
-            <a:off x="7744967" y="4261103"/>
-            <a:ext cx="3788359" cy="274320"/>
+          <p:cNvPr id="49" name="TextBox 48"/>
+          <p:cNvSpPr txBox="1"/>
+          <p:nvPr/>
+        </p:nvSpPr>
+        <p:spPr>
+          <a:xfrm>
+            <a:off x="6830568" y="3739896"/>
+            <a:ext cx="4702759" cy="164592"/>
           </a:xfrm>
           <a:prstGeom prst="rect">
             <a:avLst/>
@@ -22056,7 +22169,7 @@
               </a:lnSpc>
             </a:pPr>
             <a:r>
-              <a:rPr sz="1050" b="1" i="0">
+              <a:rPr sz="1000" b="1" i="0">
                 <a:solidFill>
                   <a:srgbClr val="2B3340"/>
                 </a:solidFill>
@@ -22069,14 +22182,14 @@
       </p:sp>
       <p:sp>
         <p:nvSpPr>
-          <p:cNvPr id="48" name="TextBox 47"/>
-          <p:cNvSpPr txBox="1"/>
-          <p:nvPr/>
-        </p:nvSpPr>
-        <p:spPr>
-          <a:xfrm>
-            <a:off x="7744967" y="4544567"/>
-            <a:ext cx="3788359" cy="274320"/>
+          <p:cNvPr id="50" name="TextBox 49"/>
+          <p:cNvSpPr txBox="1"/>
+          <p:nvPr/>
+        </p:nvSpPr>
+        <p:spPr>
+          <a:xfrm>
+            <a:off x="6830568" y="3922775"/>
+            <a:ext cx="4702759" cy="155448"/>
           </a:xfrm>
           <a:prstGeom prst="rect">
             <a:avLst/>
@@ -22095,7 +22208,7 @@
               </a:lnSpc>
             </a:pPr>
             <a:r>
-              <a:rPr sz="1000" b="0" i="0">
+              <a:rPr sz="950" b="0" i="0">
                 <a:solidFill>
                   <a:srgbClr val="535E6E"/>
                 </a:solidFill>
@@ -22108,14 +22221,14 @@
       </p:sp>
       <p:sp>
         <p:nvSpPr>
-          <p:cNvPr id="49" name="TextBox 48"/>
-          <p:cNvSpPr txBox="1"/>
-          <p:nvPr/>
-        </p:nvSpPr>
-        <p:spPr>
-          <a:xfrm>
-            <a:off x="7287768" y="4919471"/>
-            <a:ext cx="457200" cy="274320"/>
+          <p:cNvPr id="51" name="TextBox 50"/>
+          <p:cNvSpPr txBox="1"/>
+          <p:nvPr/>
+        </p:nvSpPr>
+        <p:spPr>
+          <a:xfrm>
+            <a:off x="6419088" y="4187952"/>
+            <a:ext cx="411480" cy="228600"/>
           </a:xfrm>
           <a:prstGeom prst="rect">
             <a:avLst/>
@@ -22134,7 +22247,7 @@
               </a:lnSpc>
             </a:pPr>
             <a:r>
-              <a:rPr sz="1050" b="1" i="0">
+              <a:rPr sz="1000" b="1" i="0">
                 <a:solidFill>
                   <a:srgbClr val="1F3864"/>
                 </a:solidFill>
@@ -22147,14 +22260,14 @@
       </p:sp>
       <p:sp>
         <p:nvSpPr>
-          <p:cNvPr id="50" name="TextBox 49"/>
-          <p:cNvSpPr txBox="1"/>
-          <p:nvPr/>
-        </p:nvSpPr>
-        <p:spPr>
-          <a:xfrm>
-            <a:off x="7744967" y="4919471"/>
-            <a:ext cx="3788359" cy="274320"/>
+          <p:cNvPr id="52" name="TextBox 51"/>
+          <p:cNvSpPr txBox="1"/>
+          <p:nvPr/>
+        </p:nvSpPr>
+        <p:spPr>
+          <a:xfrm>
+            <a:off x="6830568" y="4187952"/>
+            <a:ext cx="4702759" cy="164592"/>
           </a:xfrm>
           <a:prstGeom prst="rect">
             <a:avLst/>
@@ -22173,7 +22286,7 @@
               </a:lnSpc>
             </a:pPr>
             <a:r>
-              <a:rPr sz="1050" b="1" i="0">
+              <a:rPr sz="1000" b="1" i="0">
                 <a:solidFill>
                   <a:srgbClr val="2B3340"/>
                 </a:solidFill>
@@ -22186,14 +22299,14 @@
       </p:sp>
       <p:sp>
         <p:nvSpPr>
-          <p:cNvPr id="51" name="TextBox 50"/>
-          <p:cNvSpPr txBox="1"/>
-          <p:nvPr/>
-        </p:nvSpPr>
-        <p:spPr>
-          <a:xfrm>
-            <a:off x="7744967" y="5202935"/>
-            <a:ext cx="3788359" cy="274320"/>
+          <p:cNvPr id="53" name="TextBox 52"/>
+          <p:cNvSpPr txBox="1"/>
+          <p:nvPr/>
+        </p:nvSpPr>
+        <p:spPr>
+          <a:xfrm>
+            <a:off x="6830568" y="4370831"/>
+            <a:ext cx="4702759" cy="155448"/>
           </a:xfrm>
           <a:prstGeom prst="rect">
             <a:avLst/>
@@ -22212,7 +22325,7 @@
               </a:lnSpc>
             </a:pPr>
             <a:r>
-              <a:rPr sz="1000" b="0" i="0">
+              <a:rPr sz="950" b="0" i="0">
                 <a:solidFill>
                   <a:srgbClr val="535E6E"/>
                 </a:solidFill>
@@ -22225,14 +22338,14 @@
       </p:sp>
       <p:sp>
         <p:nvSpPr>
-          <p:cNvPr id="52" name="TextBox 51"/>
-          <p:cNvSpPr txBox="1"/>
-          <p:nvPr/>
-        </p:nvSpPr>
-        <p:spPr>
-          <a:xfrm>
-            <a:off x="7287768" y="5577839"/>
-            <a:ext cx="457200" cy="274320"/>
+          <p:cNvPr id="54" name="TextBox 53"/>
+          <p:cNvSpPr txBox="1"/>
+          <p:nvPr/>
+        </p:nvSpPr>
+        <p:spPr>
+          <a:xfrm>
+            <a:off x="6419088" y="4636008"/>
+            <a:ext cx="411480" cy="228600"/>
           </a:xfrm>
           <a:prstGeom prst="rect">
             <a:avLst/>
@@ -22251,7 +22364,7 @@
               </a:lnSpc>
             </a:pPr>
             <a:r>
-              <a:rPr sz="1050" b="1" i="0">
+              <a:rPr sz="1000" b="1" i="0">
                 <a:solidFill>
                   <a:srgbClr val="1F3864"/>
                 </a:solidFill>
@@ -22264,14 +22377,14 @@
       </p:sp>
       <p:sp>
         <p:nvSpPr>
-          <p:cNvPr id="53" name="TextBox 52"/>
-          <p:cNvSpPr txBox="1"/>
-          <p:nvPr/>
-        </p:nvSpPr>
-        <p:spPr>
-          <a:xfrm>
-            <a:off x="7744967" y="5577839"/>
-            <a:ext cx="3788359" cy="274320"/>
+          <p:cNvPr id="55" name="TextBox 54"/>
+          <p:cNvSpPr txBox="1"/>
+          <p:nvPr/>
+        </p:nvSpPr>
+        <p:spPr>
+          <a:xfrm>
+            <a:off x="6830568" y="4636008"/>
+            <a:ext cx="4702759" cy="164592"/>
           </a:xfrm>
           <a:prstGeom prst="rect">
             <a:avLst/>
@@ -22290,7 +22403,7 @@
               </a:lnSpc>
             </a:pPr>
             <a:r>
-              <a:rPr sz="1050" b="1" i="0">
+              <a:rPr sz="1000" b="1" i="0">
                 <a:solidFill>
                   <a:srgbClr val="2B3340"/>
                 </a:solidFill>
@@ -22303,14 +22416,14 @@
       </p:sp>
       <p:sp>
         <p:nvSpPr>
-          <p:cNvPr id="54" name="TextBox 53"/>
-          <p:cNvSpPr txBox="1"/>
-          <p:nvPr/>
-        </p:nvSpPr>
-        <p:spPr>
-          <a:xfrm>
-            <a:off x="7744967" y="5861303"/>
-            <a:ext cx="3788359" cy="274320"/>
+          <p:cNvPr id="56" name="TextBox 55"/>
+          <p:cNvSpPr txBox="1"/>
+          <p:nvPr/>
+        </p:nvSpPr>
+        <p:spPr>
+          <a:xfrm>
+            <a:off x="6830568" y="4818888"/>
+            <a:ext cx="4702759" cy="310896"/>
           </a:xfrm>
           <a:prstGeom prst="rect">
             <a:avLst/>
@@ -22329,20 +22442,137 @@
               </a:lnSpc>
             </a:pPr>
             <a:r>
-              <a:rPr sz="1000" b="0" i="0">
+              <a:rPr sz="950" b="0" i="0">
                 <a:solidFill>
                   <a:srgbClr val="535E6E"/>
                 </a:solidFill>
                 <a:latin typeface="Segoe UI"/>
               </a:rPr>
-              <a:t>→ Publicar en intranet o LMS antes de escalar.</a:t>
-            </a:r>
-          </a:p>
-        </p:txBody>
-      </p:sp>
-      <p:sp>
-        <p:nvSpPr>
-          <p:cNvPr id="55" name="Rectangle 54"/>
+              <a:t>→ No difundir el link fuera del piloto; publicar en intranet o LMS antes de escalar.</a:t>
+            </a:r>
+          </a:p>
+        </p:txBody>
+      </p:sp>
+      <p:sp>
+        <p:nvSpPr>
+          <p:cNvPr id="57" name="TextBox 56"/>
+          <p:cNvSpPr txBox="1"/>
+          <p:nvPr/>
+        </p:nvSpPr>
+        <p:spPr>
+          <a:xfrm>
+            <a:off x="6419088" y="5239512"/>
+            <a:ext cx="411480" cy="228600"/>
+          </a:xfrm>
+          <a:prstGeom prst="rect">
+            <a:avLst/>
+          </a:prstGeom>
+          <a:noFill/>
+        </p:spPr>
+        <p:txBody>
+          <a:bodyPr wrap="square" anchor="t" lIns="0" rIns="0" tIns="0" bIns="0">
+            <a:spAutoFit/>
+          </a:bodyPr>
+          <a:lstStyle/>
+          <a:p>
+            <a:pPr algn="l">
+              <a:lnSpc>
+                <a:spcPct val="100000"/>
+              </a:lnSpc>
+            </a:pPr>
+            <a:r>
+              <a:rPr sz="1000" b="1" i="0">
+                <a:solidFill>
+                  <a:srgbClr val="1F3864"/>
+                </a:solidFill>
+                <a:latin typeface="Segoe UI Semibold"/>
+              </a:rPr>
+              <a:t>R7</a:t>
+            </a:r>
+          </a:p>
+        </p:txBody>
+      </p:sp>
+      <p:sp>
+        <p:nvSpPr>
+          <p:cNvPr id="58" name="TextBox 57"/>
+          <p:cNvSpPr txBox="1"/>
+          <p:nvPr/>
+        </p:nvSpPr>
+        <p:spPr>
+          <a:xfrm>
+            <a:off x="6830568" y="5239512"/>
+            <a:ext cx="4702759" cy="329184"/>
+          </a:xfrm>
+          <a:prstGeom prst="rect">
+            <a:avLst/>
+          </a:prstGeom>
+          <a:noFill/>
+        </p:spPr>
+        <p:txBody>
+          <a:bodyPr wrap="square" anchor="t" lIns="0" rIns="0" tIns="0" bIns="0">
+            <a:spAutoFit/>
+          </a:bodyPr>
+          <a:lstStyle/>
+          <a:p>
+            <a:pPr algn="l">
+              <a:lnSpc>
+                <a:spcPct val="100000"/>
+              </a:lnSpc>
+            </a:pPr>
+            <a:r>
+              <a:rPr sz="1000" b="1" i="0">
+                <a:solidFill>
+                  <a:srgbClr val="2B3340"/>
+                </a:solidFill>
+                <a:latin typeface="Segoe UI"/>
+              </a:rPr>
+              <a:t>Los PDF de práctica circulan fuera del piloto y se usan en planta</a:t>
+            </a:r>
+          </a:p>
+        </p:txBody>
+      </p:sp>
+      <p:sp>
+        <p:nvSpPr>
+          <p:cNvPr id="59" name="TextBox 58"/>
+          <p:cNvSpPr txBox="1"/>
+          <p:nvPr/>
+        </p:nvSpPr>
+        <p:spPr>
+          <a:xfrm>
+            <a:off x="6830568" y="5586984"/>
+            <a:ext cx="4702759" cy="310896"/>
+          </a:xfrm>
+          <a:prstGeom prst="rect">
+            <a:avLst/>
+          </a:prstGeom>
+          <a:noFill/>
+        </p:spPr>
+        <p:txBody>
+          <a:bodyPr wrap="square" anchor="t" lIns="0" rIns="0" tIns="0" bIns="0">
+            <a:spAutoFit/>
+          </a:bodyPr>
+          <a:lstStyle/>
+          <a:p>
+            <a:pPr algn="l">
+              <a:lnSpc>
+                <a:spcPct val="100000"/>
+              </a:lnSpc>
+            </a:pPr>
+            <a:r>
+              <a:rPr sz="950" b="0" i="0">
+                <a:solidFill>
+                  <a:srgbClr val="535E6E"/>
+                </a:solidFill>
+                <a:latin typeface="Segoe UI"/>
+              </a:rPr>
+              <a:t>→ Marca DEMO, sin copias impresas; Seguridad recuerda que solo vale el formato aprobado.</a:t>
+            </a:r>
+          </a:p>
+        </p:txBody>
+      </p:sp>
+      <p:sp>
+        <p:nvSpPr>
+          <p:cNvPr id="60" name="Rectangle 59"/>
           <p:cNvSpPr/>
           <p:nvPr/>
         </p:nvSpPr>
@@ -22386,7 +22616,7 @@
       </p:sp>
       <p:sp>
         <p:nvSpPr>
-          <p:cNvPr id="56" name="TextBox 55"/>
+          <p:cNvPr id="61" name="TextBox 60"/>
           <p:cNvSpPr txBox="1"/>
           <p:nvPr/>
         </p:nvSpPr>
@@ -22425,7 +22655,7 @@
       </p:sp>
       <p:sp>
         <p:nvSpPr>
-          <p:cNvPr id="57" name="TextBox 56"/>
+          <p:cNvPr id="62" name="TextBox 61"/>
           <p:cNvSpPr txBox="1"/>
           <p:nvPr/>
         </p:nvSpPr>

</xml_diff>